<commit_message>
Weave README.kr.md usage content into the seminar deck (12->16 slides)
Add a 'Part 2. 실전 사용' section to the PowerPoint deck derived from
README.kr.md: environment setup & kernel install, demo & Python API,
accuracy benchmarks (RULER/LongBench/Reasoning), and throughput
reproduction & extension. Renumber the summary slide to 16, update
build_deck.js output path to relative, and refresh seminar/README.md.

Co-Authored-By: Claude Opus 4.8 <noreply@anthropic.com>
Claude-Session: https://claude.ai/code/session_01Htg7ngmuMobZBwsx9JdYWQ
</commit_message>
<xml_diff>
--- a/seminar/RetroInfer_세미나.pptx
+++ b/seminar/RetroInfer_세미나.pptx
@@ -17,9 +17,13 @@
     <p:sldId id="265" r:id="rId11"/>
     <p:sldId id="266" r:id="rId12"/>
     <p:sldId id="267" r:id="rId13"/>
+    <p:sldId id="268" r:id="rId14"/>
+    <p:sldId id="269" r:id="rId15"/>
+    <p:sldId id="270" r:id="rId16"/>
+    <p:sldId id="271" r:id="rId17"/>
   </p:sldIdLst>
   <p:notesMasterIdLst>
-    <p:notesMasterId r:id="rId14"/>
+    <p:notesMasterId r:id="rId18"/>
   </p:notesMasterIdLst>
   <p:sldSz cx="12192000" cy="6858000"/>
   <p:notesSz cx="6858000" cy="12192000"/>
@@ -1050,6 +1054,358 @@
 </p:notes>
 </file>
 
+<file path=ppt/notesSlides/notesSlide13.xml><?xml version="1.0" encoding="utf-8"?>
+<p:notes xmlns:a="http://schemas.openxmlformats.org/drawingml/2006/main" xmlns:r="http://schemas.openxmlformats.org/officeDocument/2006/relationships" xmlns:p="http://schemas.openxmlformats.org/presentationml/2006/main">
+  <p:cSld>
+    <p:spTree>
+      <p:nvGrpSpPr>
+        <p:cNvPr id="1" name=""/>
+        <p:cNvGrpSpPr/>
+        <p:nvPr/>
+      </p:nvGrpSpPr>
+      <p:grpSpPr>
+        <a:xfrm>
+          <a:off x="0" y="0"/>
+          <a:ext cx="0" cy="0"/>
+          <a:chOff x="0" y="0"/>
+          <a:chExt cx="0" cy="0"/>
+        </a:xfrm>
+      </p:grpSpPr>
+      <p:sp>
+        <p:nvSpPr>
+          <p:cNvPr id="2" name="Slide Image Placeholder 1"/>
+          <p:cNvSpPr>
+            <a:spLocks noGrp="1" noRot="1" noChangeAspect="1"/>
+          </p:cNvSpPr>
+          <p:nvPr>
+            <p:ph type="sldImg"/>
+          </p:nvPr>
+        </p:nvSpPr>
+        <p:spPr/>
+      </p:sp>
+      <p:sp>
+        <p:nvSpPr>
+          <p:cNvPr id="3" name="Notes Placeholder 2"/>
+          <p:cNvSpPr>
+            <a:spLocks noGrp="1"/>
+          </p:cNvSpPr>
+          <p:nvPr>
+            <p:ph type="body" idx="1"/>
+          </p:nvPr>
+        </p:nvSpPr>
+        <p:spPr/>
+        <p:txBody>
+          <a:bodyPr/>
+          <a:lstStyle/>
+          <a:p>
+            <a:r>
+              <a:rPr lang="en-US" dirty="0"/>
+              <a:t/>
+            </a:r>
+            <a:endParaRPr lang="en-US" dirty="0"/>
+          </a:p>
+        </p:txBody>
+      </p:sp>
+      <p:sp>
+        <p:nvSpPr>
+          <p:cNvPr id="4" name="Slide Number Placeholder 3"/>
+          <p:cNvSpPr>
+            <a:spLocks noGrp="1"/>
+          </p:cNvSpPr>
+          <p:nvPr>
+            <p:ph type="sldNum" sz="quarter" idx="10"/>
+          </p:nvPr>
+        </p:nvSpPr>
+        <p:spPr/>
+        <p:txBody>
+          <a:bodyPr/>
+          <a:lstStyle/>
+          <a:p>
+            <a:fld id="{F7021451-1387-4CA6-816F-3879F97B5CBC}" type="slidenum">
+              <a:rPr lang="en-US"/>
+              <a:t>13</a:t>
+            </a:fld>
+            <a:endParaRPr lang="en-US"/>
+          </a:p>
+        </p:txBody>
+      </p:sp>
+    </p:spTree>
+    <p:extLst>
+      <p:ext uri="{BB962C8B-B14F-4D97-AF65-F5344CB8AC3E}">
+        <p14:creationId xmlns:p14="http://schemas.microsoft.com/office/powerpoint/2010/main" val="1024086991"/>
+      </p:ext>
+    </p:extLst>
+  </p:cSld>
+  <p:clrMapOvr>
+    <a:masterClrMapping/>
+  </p:clrMapOvr>
+</p:notes>
+</file>
+
+<file path=ppt/notesSlides/notesSlide14.xml><?xml version="1.0" encoding="utf-8"?>
+<p:notes xmlns:a="http://schemas.openxmlformats.org/drawingml/2006/main" xmlns:r="http://schemas.openxmlformats.org/officeDocument/2006/relationships" xmlns:p="http://schemas.openxmlformats.org/presentationml/2006/main">
+  <p:cSld>
+    <p:spTree>
+      <p:nvGrpSpPr>
+        <p:cNvPr id="1" name=""/>
+        <p:cNvGrpSpPr/>
+        <p:nvPr/>
+      </p:nvGrpSpPr>
+      <p:grpSpPr>
+        <a:xfrm>
+          <a:off x="0" y="0"/>
+          <a:ext cx="0" cy="0"/>
+          <a:chOff x="0" y="0"/>
+          <a:chExt cx="0" cy="0"/>
+        </a:xfrm>
+      </p:grpSpPr>
+      <p:sp>
+        <p:nvSpPr>
+          <p:cNvPr id="2" name="Slide Image Placeholder 1"/>
+          <p:cNvSpPr>
+            <a:spLocks noGrp="1" noRot="1" noChangeAspect="1"/>
+          </p:cNvSpPr>
+          <p:nvPr>
+            <p:ph type="sldImg"/>
+          </p:nvPr>
+        </p:nvSpPr>
+        <p:spPr/>
+      </p:sp>
+      <p:sp>
+        <p:nvSpPr>
+          <p:cNvPr id="3" name="Notes Placeholder 2"/>
+          <p:cNvSpPr>
+            <a:spLocks noGrp="1"/>
+          </p:cNvSpPr>
+          <p:nvPr>
+            <p:ph type="body" idx="1"/>
+          </p:nvPr>
+        </p:nvSpPr>
+        <p:spPr/>
+        <p:txBody>
+          <a:bodyPr/>
+          <a:lstStyle/>
+          <a:p>
+            <a:r>
+              <a:rPr lang="en-US" dirty="0"/>
+              <a:t/>
+            </a:r>
+            <a:endParaRPr lang="en-US" dirty="0"/>
+          </a:p>
+        </p:txBody>
+      </p:sp>
+      <p:sp>
+        <p:nvSpPr>
+          <p:cNvPr id="4" name="Slide Number Placeholder 3"/>
+          <p:cNvSpPr>
+            <a:spLocks noGrp="1"/>
+          </p:cNvSpPr>
+          <p:nvPr>
+            <p:ph type="sldNum" sz="quarter" idx="10"/>
+          </p:nvPr>
+        </p:nvSpPr>
+        <p:spPr/>
+        <p:txBody>
+          <a:bodyPr/>
+          <a:lstStyle/>
+          <a:p>
+            <a:fld id="{F7021451-1387-4CA6-816F-3879F97B5CBC}" type="slidenum">
+              <a:rPr lang="en-US"/>
+              <a:t>14</a:t>
+            </a:fld>
+            <a:endParaRPr lang="en-US"/>
+          </a:p>
+        </p:txBody>
+      </p:sp>
+    </p:spTree>
+    <p:extLst>
+      <p:ext uri="{BB962C8B-B14F-4D97-AF65-F5344CB8AC3E}">
+        <p14:creationId xmlns:p14="http://schemas.microsoft.com/office/powerpoint/2010/main" val="1024086991"/>
+      </p:ext>
+    </p:extLst>
+  </p:cSld>
+  <p:clrMapOvr>
+    <a:masterClrMapping/>
+  </p:clrMapOvr>
+</p:notes>
+</file>
+
+<file path=ppt/notesSlides/notesSlide15.xml><?xml version="1.0" encoding="utf-8"?>
+<p:notes xmlns:a="http://schemas.openxmlformats.org/drawingml/2006/main" xmlns:r="http://schemas.openxmlformats.org/officeDocument/2006/relationships" xmlns:p="http://schemas.openxmlformats.org/presentationml/2006/main">
+  <p:cSld>
+    <p:spTree>
+      <p:nvGrpSpPr>
+        <p:cNvPr id="1" name=""/>
+        <p:cNvGrpSpPr/>
+        <p:nvPr/>
+      </p:nvGrpSpPr>
+      <p:grpSpPr>
+        <a:xfrm>
+          <a:off x="0" y="0"/>
+          <a:ext cx="0" cy="0"/>
+          <a:chOff x="0" y="0"/>
+          <a:chExt cx="0" cy="0"/>
+        </a:xfrm>
+      </p:grpSpPr>
+      <p:sp>
+        <p:nvSpPr>
+          <p:cNvPr id="2" name="Slide Image Placeholder 1"/>
+          <p:cNvSpPr>
+            <a:spLocks noGrp="1" noRot="1" noChangeAspect="1"/>
+          </p:cNvSpPr>
+          <p:nvPr>
+            <p:ph type="sldImg"/>
+          </p:nvPr>
+        </p:nvSpPr>
+        <p:spPr/>
+      </p:sp>
+      <p:sp>
+        <p:nvSpPr>
+          <p:cNvPr id="3" name="Notes Placeholder 2"/>
+          <p:cNvSpPr>
+            <a:spLocks noGrp="1"/>
+          </p:cNvSpPr>
+          <p:nvPr>
+            <p:ph type="body" idx="1"/>
+          </p:nvPr>
+        </p:nvSpPr>
+        <p:spPr/>
+        <p:txBody>
+          <a:bodyPr/>
+          <a:lstStyle/>
+          <a:p>
+            <a:r>
+              <a:rPr lang="en-US" dirty="0"/>
+              <a:t/>
+            </a:r>
+            <a:endParaRPr lang="en-US" dirty="0"/>
+          </a:p>
+        </p:txBody>
+      </p:sp>
+      <p:sp>
+        <p:nvSpPr>
+          <p:cNvPr id="4" name="Slide Number Placeholder 3"/>
+          <p:cNvSpPr>
+            <a:spLocks noGrp="1"/>
+          </p:cNvSpPr>
+          <p:nvPr>
+            <p:ph type="sldNum" sz="quarter" idx="10"/>
+          </p:nvPr>
+        </p:nvSpPr>
+        <p:spPr/>
+        <p:txBody>
+          <a:bodyPr/>
+          <a:lstStyle/>
+          <a:p>
+            <a:fld id="{F7021451-1387-4CA6-816F-3879F97B5CBC}" type="slidenum">
+              <a:rPr lang="en-US"/>
+              <a:t>15</a:t>
+            </a:fld>
+            <a:endParaRPr lang="en-US"/>
+          </a:p>
+        </p:txBody>
+      </p:sp>
+    </p:spTree>
+    <p:extLst>
+      <p:ext uri="{BB962C8B-B14F-4D97-AF65-F5344CB8AC3E}">
+        <p14:creationId xmlns:p14="http://schemas.microsoft.com/office/powerpoint/2010/main" val="1024086991"/>
+      </p:ext>
+    </p:extLst>
+  </p:cSld>
+  <p:clrMapOvr>
+    <a:masterClrMapping/>
+  </p:clrMapOvr>
+</p:notes>
+</file>
+
+<file path=ppt/notesSlides/notesSlide16.xml><?xml version="1.0" encoding="utf-8"?>
+<p:notes xmlns:a="http://schemas.openxmlformats.org/drawingml/2006/main" xmlns:r="http://schemas.openxmlformats.org/officeDocument/2006/relationships" xmlns:p="http://schemas.openxmlformats.org/presentationml/2006/main">
+  <p:cSld>
+    <p:spTree>
+      <p:nvGrpSpPr>
+        <p:cNvPr id="1" name=""/>
+        <p:cNvGrpSpPr/>
+        <p:nvPr/>
+      </p:nvGrpSpPr>
+      <p:grpSpPr>
+        <a:xfrm>
+          <a:off x="0" y="0"/>
+          <a:ext cx="0" cy="0"/>
+          <a:chOff x="0" y="0"/>
+          <a:chExt cx="0" cy="0"/>
+        </a:xfrm>
+      </p:grpSpPr>
+      <p:sp>
+        <p:nvSpPr>
+          <p:cNvPr id="2" name="Slide Image Placeholder 1"/>
+          <p:cNvSpPr>
+            <a:spLocks noGrp="1" noRot="1" noChangeAspect="1"/>
+          </p:cNvSpPr>
+          <p:nvPr>
+            <p:ph type="sldImg"/>
+          </p:nvPr>
+        </p:nvSpPr>
+        <p:spPr/>
+      </p:sp>
+      <p:sp>
+        <p:nvSpPr>
+          <p:cNvPr id="3" name="Notes Placeholder 2"/>
+          <p:cNvSpPr>
+            <a:spLocks noGrp="1"/>
+          </p:cNvSpPr>
+          <p:nvPr>
+            <p:ph type="body" idx="1"/>
+          </p:nvPr>
+        </p:nvSpPr>
+        <p:spPr/>
+        <p:txBody>
+          <a:bodyPr/>
+          <a:lstStyle/>
+          <a:p>
+            <a:r>
+              <a:rPr lang="en-US" dirty="0"/>
+              <a:t/>
+            </a:r>
+            <a:endParaRPr lang="en-US" dirty="0"/>
+          </a:p>
+        </p:txBody>
+      </p:sp>
+      <p:sp>
+        <p:nvSpPr>
+          <p:cNvPr id="4" name="Slide Number Placeholder 3"/>
+          <p:cNvSpPr>
+            <a:spLocks noGrp="1"/>
+          </p:cNvSpPr>
+          <p:nvPr>
+            <p:ph type="sldNum" sz="quarter" idx="10"/>
+          </p:nvPr>
+        </p:nvSpPr>
+        <p:spPr/>
+        <p:txBody>
+          <a:bodyPr/>
+          <a:lstStyle/>
+          <a:p>
+            <a:fld id="{F7021451-1387-4CA6-816F-3879F97B5CBC}" type="slidenum">
+              <a:rPr lang="en-US"/>
+              <a:t>16</a:t>
+            </a:fld>
+            <a:endParaRPr lang="en-US"/>
+          </a:p>
+        </p:txBody>
+      </p:sp>
+    </p:spTree>
+    <p:extLst>
+      <p:ext uri="{BB962C8B-B14F-4D97-AF65-F5344CB8AC3E}">
+        <p14:creationId xmlns:p14="http://schemas.microsoft.com/office/powerpoint/2010/main" val="1024086991"/>
+      </p:ext>
+    </p:extLst>
+  </p:cSld>
+  <p:clrMapOvr>
+    <a:masterClrMapping/>
+  </p:clrMapOvr>
+</p:notes>
+</file>
+
 <file path=ppt/notesSlides/notesSlide2.xml><?xml version="1.0" encoding="utf-8"?>
 <p:notes xmlns:a="http://schemas.openxmlformats.org/drawingml/2006/main" xmlns:r="http://schemas.openxmlformats.org/officeDocument/2006/relationships" xmlns:p="http://schemas.openxmlformats.org/presentationml/2006/main">
   <p:cSld>
@@ -4871,6 +5227,3949 @@
     <p:bg>
       <p:bgPr>
         <a:solidFill>
+          <a:srgbClr val="FFFFFF"/>
+        </a:solidFill>
+      </p:bgPr>
+    </p:bg>
+    <p:spTree>
+      <p:nvGrpSpPr>
+        <p:cNvPr id="1" name=""/>
+        <p:cNvGrpSpPr/>
+        <p:nvPr/>
+      </p:nvGrpSpPr>
+      <p:grpSpPr>
+        <a:xfrm>
+          <a:off x="0" y="0"/>
+          <a:ext cx="0" cy="0"/>
+          <a:chOff x="0" y="0"/>
+          <a:chExt cx="0" cy="0"/>
+        </a:xfrm>
+      </p:grpSpPr>
+      <p:sp>
+        <p:nvSpPr>
+          <p:cNvPr id="2" name="Text 0"/>
+          <p:cNvSpPr/>
+          <p:nvPr/>
+        </p:nvSpPr>
+        <p:spPr>
+          <a:xfrm>
+            <a:off x="548640" y="411480"/>
+            <a:ext cx="11091672" cy="640080"/>
+          </a:xfrm>
+          <a:prstGeom prst="rect">
+            <a:avLst/>
+          </a:prstGeom>
+          <a:noFill/>
+          <a:ln/>
+        </p:spPr>
+        <p:txBody>
+          <a:bodyPr wrap="square" lIns="0" tIns="0" rIns="0" bIns="0" rtlCol="0" anchor="ctr"/>
+          <a:lstStyle/>
+          <a:p>
+            <a:pPr indent="0" marL="0">
+              <a:buNone/>
+            </a:pPr>
+            <a:r>
+              <a:rPr lang="en-US" sz="3000" b="1" dirty="0">
+                <a:solidFill>
+                  <a:srgbClr val="0F172A"/>
+                </a:solidFill>
+                <a:latin typeface="Malgun Gothic" pitchFamily="34" charset="0"/>
+                <a:ea typeface="Malgun Gothic" pitchFamily="34" charset="-122"/>
+                <a:cs typeface="Malgun Gothic" pitchFamily="34" charset="-120"/>
+              </a:rPr>
+              <a:t>실전 ① 환경 설정 &amp; 커널 설치</a:t>
+            </a:r>
+            <a:endParaRPr lang="en-US" sz="3000" dirty="0"/>
+          </a:p>
+        </p:txBody>
+      </p:sp>
+      <p:sp>
+        <p:nvSpPr>
+          <p:cNvPr id="3" name="Text 1"/>
+          <p:cNvSpPr/>
+          <p:nvPr/>
+        </p:nvSpPr>
+        <p:spPr>
+          <a:xfrm>
+            <a:off x="566928" y="1060704"/>
+            <a:ext cx="11091672" cy="365760"/>
+          </a:xfrm>
+          <a:prstGeom prst="rect">
+            <a:avLst/>
+          </a:prstGeom>
+          <a:noFill/>
+          <a:ln/>
+        </p:spPr>
+        <p:txBody>
+          <a:bodyPr wrap="square" lIns="0" tIns="0" rIns="0" bIns="0" rtlCol="0" anchor="ctr"/>
+          <a:lstStyle/>
+          <a:p>
+            <a:pPr indent="0" marL="0">
+              <a:buNone/>
+            </a:pPr>
+            <a:r>
+              <a:rPr lang="en-US" sz="1400" b="1" dirty="0">
+                <a:solidFill>
+                  <a:srgbClr val="14B8A6"/>
+                </a:solidFill>
+                <a:latin typeface="Malgun Gothic" pitchFamily="34" charset="0"/>
+                <a:ea typeface="Malgun Gothic" pitchFamily="34" charset="-122"/>
+                <a:cs typeface="Malgun Gothic" pitchFamily="34" charset="-120"/>
+              </a:rPr>
+              <a:t>CUDA 12.4 · Python 3.10.16 · conda 권장 (README.kr.md)</a:t>
+            </a:r>
+            <a:endParaRPr lang="en-US" sz="1400" dirty="0"/>
+          </a:p>
+        </p:txBody>
+      </p:sp>
+      <p:sp>
+        <p:nvSpPr>
+          <p:cNvPr id="4" name="Text 2"/>
+          <p:cNvSpPr/>
+          <p:nvPr/>
+        </p:nvSpPr>
+        <p:spPr>
+          <a:xfrm>
+            <a:off x="548640" y="1783080"/>
+            <a:ext cx="5486400" cy="329184"/>
+          </a:xfrm>
+          <a:prstGeom prst="rect">
+            <a:avLst/>
+          </a:prstGeom>
+          <a:noFill/>
+          <a:ln/>
+        </p:spPr>
+        <p:txBody>
+          <a:bodyPr wrap="square" lIns="0" tIns="0" rIns="0" bIns="0" rtlCol="0" anchor="ctr"/>
+          <a:lstStyle/>
+          <a:p>
+            <a:pPr indent="0" marL="0">
+              <a:buNone/>
+            </a:pPr>
+            <a:r>
+              <a:rPr lang="en-US" sz="1500" b="1" dirty="0">
+                <a:solidFill>
+                  <a:srgbClr val="0F766E"/>
+                </a:solidFill>
+                <a:latin typeface="Malgun Gothic" pitchFamily="34" charset="0"/>
+                <a:ea typeface="Malgun Gothic" pitchFamily="34" charset="-122"/>
+                <a:cs typeface="Malgun Gothic" pitchFamily="34" charset="-120"/>
+              </a:rPr>
+              <a:t>1. 패키지 설치</a:t>
+            </a:r>
+            <a:endParaRPr lang="en-US" sz="1500" dirty="0"/>
+          </a:p>
+        </p:txBody>
+      </p:sp>
+      <p:sp>
+        <p:nvSpPr>
+          <p:cNvPr id="5" name="Shape 3"/>
+          <p:cNvSpPr/>
+          <p:nvPr/>
+        </p:nvSpPr>
+        <p:spPr>
+          <a:xfrm>
+            <a:off x="548640" y="2148840"/>
+            <a:ext cx="5486400" cy="2880360"/>
+          </a:xfrm>
+          <a:prstGeom prst="roundRect">
+            <a:avLst>
+              <a:gd name="adj" fmla="val 1905"/>
+            </a:avLst>
+          </a:prstGeom>
+          <a:solidFill>
+            <a:srgbClr val="0F172A"/>
+          </a:solidFill>
+          <a:ln/>
+        </p:spPr>
+      </p:sp>
+      <p:sp>
+        <p:nvSpPr>
+          <p:cNvPr id="6" name="Text 4"/>
+          <p:cNvSpPr/>
+          <p:nvPr/>
+        </p:nvSpPr>
+        <p:spPr>
+          <a:xfrm>
+            <a:off x="713232" y="2258568"/>
+            <a:ext cx="5157216" cy="2660904"/>
+          </a:xfrm>
+          <a:prstGeom prst="rect">
+            <a:avLst/>
+          </a:prstGeom>
+          <a:noFill/>
+          <a:ln/>
+        </p:spPr>
+        <p:txBody>
+          <a:bodyPr wrap="square" lIns="0" tIns="0" rIns="0" bIns="0" rtlCol="0" anchor="t"/>
+          <a:lstStyle/>
+          <a:p>
+            <a:pPr indent="0" marL="0">
+              <a:lnSpc>
+                <a:spcPct val="114000"/>
+              </a:lnSpc>
+              <a:buNone/>
+            </a:pPr>
+            <a:r>
+              <a:rPr lang="en-US" sz="1050" dirty="0">
+                <a:solidFill>
+                  <a:srgbClr val="E2E8F0"/>
+                </a:solidFill>
+                <a:latin typeface="Consolas" pitchFamily="34" charset="0"/>
+                <a:ea typeface="Consolas" pitchFamily="34" charset="-122"/>
+                <a:cs typeface="Consolas" pitchFamily="34" charset="-120"/>
+              </a:rPr>
+              <a:t>conda create -n retroinfer python=3.10 -y</a:t>
+            </a:r>
+            <a:endParaRPr lang="en-US" sz="1050" dirty="0"/>
+          </a:p>
+          <a:p>
+            <a:pPr indent="0" marL="0">
+              <a:lnSpc>
+                <a:spcPct val="114000"/>
+              </a:lnSpc>
+              <a:buNone/>
+            </a:pPr>
+            <a:r>
+              <a:rPr lang="en-US" sz="1050" dirty="0">
+                <a:solidFill>
+                  <a:srgbClr val="E2E8F0"/>
+                </a:solidFill>
+                <a:latin typeface="Consolas" pitchFamily="34" charset="0"/>
+                <a:ea typeface="Consolas" pitchFamily="34" charset="-122"/>
+                <a:cs typeface="Consolas" pitchFamily="34" charset="-120"/>
+              </a:rPr>
+              <a:t>conda activate retroinfer</a:t>
+            </a:r>
+            <a:endParaRPr lang="en-US" sz="1050" dirty="0"/>
+          </a:p>
+          <a:p>
+            <a:pPr indent="0" marL="0">
+              <a:lnSpc>
+                <a:spcPct val="114000"/>
+              </a:lnSpc>
+              <a:buNone/>
+            </a:pPr>
+            <a:r>
+              <a:rPr lang="en-US" sz="1050" dirty="0">
+                <a:solidFill>
+                  <a:srgbClr val="E2E8F0"/>
+                </a:solidFill>
+                <a:latin typeface="Consolas" pitchFamily="34" charset="0"/>
+                <a:ea typeface="Consolas" pitchFamily="34" charset="-122"/>
+                <a:cs typeface="Consolas" pitchFamily="34" charset="-120"/>
+              </a:rPr>
+              <a:t>conda install -y mkl</a:t>
+            </a:r>
+            <a:endParaRPr lang="en-US" sz="1050" dirty="0"/>
+          </a:p>
+          <a:p>
+            <a:pPr indent="0" marL="0">
+              <a:lnSpc>
+                <a:spcPct val="114000"/>
+              </a:lnSpc>
+              <a:buNone/>
+            </a:pPr>
+            <a:r>
+              <a:rPr lang="en-US" sz="1050" dirty="0">
+                <a:solidFill>
+                  <a:srgbClr val="E2E8F0"/>
+                </a:solidFill>
+                <a:latin typeface="Consolas" pitchFamily="34" charset="0"/>
+                <a:ea typeface="Consolas" pitchFamily="34" charset="-122"/>
+                <a:cs typeface="Consolas" pitchFamily="34" charset="-120"/>
+              </a:rPr>
+              <a:t>conda install -c conda-forge libstdcxx-ng -y</a:t>
+            </a:r>
+            <a:endParaRPr lang="en-US" sz="1050" dirty="0"/>
+          </a:p>
+          <a:p>
+            <a:pPr indent="0" marL="0">
+              <a:lnSpc>
+                <a:spcPct val="114000"/>
+              </a:lnSpc>
+              <a:buNone/>
+            </a:pPr>
+            <a:endParaRPr lang="en-US" sz="1050" dirty="0"/>
+          </a:p>
+          <a:p>
+            <a:pPr indent="0" marL="0">
+              <a:lnSpc>
+                <a:spcPct val="114000"/>
+              </a:lnSpc>
+              <a:buNone/>
+            </a:pPr>
+            <a:r>
+              <a:rPr lang="en-US" sz="1050" dirty="0">
+                <a:solidFill>
+                  <a:srgbClr val="E2E8F0"/>
+                </a:solidFill>
+                <a:latin typeface="Consolas" pitchFamily="34" charset="0"/>
+                <a:ea typeface="Consolas" pitchFamily="34" charset="-122"/>
+                <a:cs typeface="Consolas" pitchFamily="34" charset="-120"/>
+              </a:rPr>
+              <a:t>pip install -r requirements.txt</a:t>
+            </a:r>
+            <a:endParaRPr lang="en-US" sz="1050" dirty="0"/>
+          </a:p>
+          <a:p>
+            <a:pPr indent="0" marL="0">
+              <a:lnSpc>
+                <a:spcPct val="114000"/>
+              </a:lnSpc>
+              <a:buNone/>
+            </a:pPr>
+            <a:r>
+              <a:rPr lang="en-US" sz="1050" dirty="0">
+                <a:solidFill>
+                  <a:srgbClr val="E2E8F0"/>
+                </a:solidFill>
+                <a:latin typeface="Consolas" pitchFamily="34" charset="0"/>
+                <a:ea typeface="Consolas" pitchFamily="34" charset="-122"/>
+                <a:cs typeface="Consolas" pitchFamily="34" charset="-120"/>
+              </a:rPr>
+              <a:t>pip install flash-attn==2.7.3 \</a:t>
+            </a:r>
+            <a:endParaRPr lang="en-US" sz="1050" dirty="0"/>
+          </a:p>
+          <a:p>
+            <a:pPr indent="0" marL="0">
+              <a:lnSpc>
+                <a:spcPct val="114000"/>
+              </a:lnSpc>
+              <a:buNone/>
+            </a:pPr>
+            <a:r>
+              <a:rPr lang="en-US" sz="1050" dirty="0">
+                <a:solidFill>
+                  <a:srgbClr val="E2E8F0"/>
+                </a:solidFill>
+                <a:latin typeface="Consolas" pitchFamily="34" charset="0"/>
+                <a:ea typeface="Consolas" pitchFamily="34" charset="-122"/>
+                <a:cs typeface="Consolas" pitchFamily="34" charset="-120"/>
+              </a:rPr>
+              <a:t>    --no-build-isolation</a:t>
+            </a:r>
+            <a:endParaRPr lang="en-US" sz="1050" dirty="0"/>
+          </a:p>
+          <a:p>
+            <a:pPr indent="0" marL="0">
+              <a:lnSpc>
+                <a:spcPct val="114000"/>
+              </a:lnSpc>
+              <a:buNone/>
+            </a:pPr>
+            <a:r>
+              <a:rPr lang="en-US" sz="1050" dirty="0">
+                <a:solidFill>
+                  <a:srgbClr val="E2E8F0"/>
+                </a:solidFill>
+                <a:latin typeface="Consolas" pitchFamily="34" charset="0"/>
+                <a:ea typeface="Consolas" pitchFamily="34" charset="-122"/>
+                <a:cs typeface="Consolas" pitchFamily="34" charset="-120"/>
+              </a:rPr>
+              <a:t>pip install flashinfer-python==0.2.4 \</a:t>
+            </a:r>
+            <a:endParaRPr lang="en-US" sz="1050" dirty="0"/>
+          </a:p>
+          <a:p>
+            <a:pPr indent="0" marL="0">
+              <a:lnSpc>
+                <a:spcPct val="114000"/>
+              </a:lnSpc>
+              <a:buNone/>
+            </a:pPr>
+            <a:r>
+              <a:rPr lang="en-US" sz="1050" dirty="0">
+                <a:solidFill>
+                  <a:srgbClr val="E2E8F0"/>
+                </a:solidFill>
+                <a:latin typeface="Consolas" pitchFamily="34" charset="0"/>
+                <a:ea typeface="Consolas" pitchFamily="34" charset="-122"/>
+                <a:cs typeface="Consolas" pitchFamily="34" charset="-120"/>
+              </a:rPr>
+              <a:t>    -i https://flashinfer.ai/whl/cu124/torch2.5/</a:t>
+            </a:r>
+            <a:endParaRPr lang="en-US" sz="1050" dirty="0"/>
+          </a:p>
+          <a:p>
+            <a:pPr indent="0" marL="0">
+              <a:lnSpc>
+                <a:spcPct val="114000"/>
+              </a:lnSpc>
+              <a:buNone/>
+            </a:pPr>
+            <a:r>
+              <a:rPr lang="en-US" sz="1050" dirty="0">
+                <a:solidFill>
+                  <a:srgbClr val="E2E8F0"/>
+                </a:solidFill>
+                <a:latin typeface="Consolas" pitchFamily="34" charset="0"/>
+                <a:ea typeface="Consolas" pitchFamily="34" charset="-122"/>
+                <a:cs typeface="Consolas" pitchFamily="34" charset="-120"/>
+              </a:rPr>
+              <a:t>pip install git+.../Starmys/\</a:t>
+            </a:r>
+            <a:endParaRPr lang="en-US" sz="1050" dirty="0"/>
+          </a:p>
+          <a:p>
+            <a:pPr indent="0" marL="0">
+              <a:lnSpc>
+                <a:spcPct val="114000"/>
+              </a:lnSpc>
+              <a:buNone/>
+            </a:pPr>
+            <a:r>
+              <a:rPr lang="en-US" sz="1050" dirty="0">
+                <a:solidFill>
+                  <a:srgbClr val="E2E8F0"/>
+                </a:solidFill>
+                <a:latin typeface="Consolas" pitchFamily="34" charset="0"/>
+                <a:ea typeface="Consolas" pitchFamily="34" charset="-122"/>
+                <a:cs typeface="Consolas" pitchFamily="34" charset="-120"/>
+              </a:rPr>
+              <a:t>    flash-attention.git@weighted</a:t>
+            </a:r>
+            <a:endParaRPr lang="en-US" sz="1050" dirty="0"/>
+          </a:p>
+        </p:txBody>
+      </p:sp>
+      <p:sp>
+        <p:nvSpPr>
+          <p:cNvPr id="7" name="Text 5"/>
+          <p:cNvSpPr/>
+          <p:nvPr/>
+        </p:nvSpPr>
+        <p:spPr>
+          <a:xfrm>
+            <a:off x="6309360" y="1783080"/>
+            <a:ext cx="5303520" cy="329184"/>
+          </a:xfrm>
+          <a:prstGeom prst="rect">
+            <a:avLst/>
+          </a:prstGeom>
+          <a:noFill/>
+          <a:ln/>
+        </p:spPr>
+        <p:txBody>
+          <a:bodyPr wrap="square" lIns="0" tIns="0" rIns="0" bIns="0" rtlCol="0" anchor="ctr"/>
+          <a:lstStyle/>
+          <a:p>
+            <a:pPr indent="0" marL="0">
+              <a:buNone/>
+            </a:pPr>
+            <a:r>
+              <a:rPr lang="en-US" sz="1500" b="1" dirty="0">
+                <a:solidFill>
+                  <a:srgbClr val="1E3A8A"/>
+                </a:solidFill>
+                <a:latin typeface="Malgun Gothic" pitchFamily="34" charset="0"/>
+                <a:ea typeface="Malgun Gothic" pitchFamily="34" charset="-122"/>
+                <a:cs typeface="Malgun Gothic" pitchFamily="34" charset="-120"/>
+              </a:rPr>
+              <a:t>2. 커널 빌드</a:t>
+            </a:r>
+            <a:endParaRPr lang="en-US" sz="1500" dirty="0"/>
+          </a:p>
+        </p:txBody>
+      </p:sp>
+      <p:sp>
+        <p:nvSpPr>
+          <p:cNvPr id="8" name="Shape 6"/>
+          <p:cNvSpPr/>
+          <p:nvPr/>
+        </p:nvSpPr>
+        <p:spPr>
+          <a:xfrm>
+            <a:off x="6309360" y="2148840"/>
+            <a:ext cx="5303520" cy="2880360"/>
+          </a:xfrm>
+          <a:prstGeom prst="roundRect">
+            <a:avLst>
+              <a:gd name="adj" fmla="val 1905"/>
+            </a:avLst>
+          </a:prstGeom>
+          <a:solidFill>
+            <a:srgbClr val="0F172A"/>
+          </a:solidFill>
+          <a:ln/>
+        </p:spPr>
+      </p:sp>
+      <p:sp>
+        <p:nvSpPr>
+          <p:cNvPr id="9" name="Text 7"/>
+          <p:cNvSpPr/>
+          <p:nvPr/>
+        </p:nvSpPr>
+        <p:spPr>
+          <a:xfrm>
+            <a:off x="6473952" y="2258568"/>
+            <a:ext cx="4974336" cy="2660904"/>
+          </a:xfrm>
+          <a:prstGeom prst="rect">
+            <a:avLst/>
+          </a:prstGeom>
+          <a:noFill/>
+          <a:ln/>
+        </p:spPr>
+        <p:txBody>
+          <a:bodyPr wrap="square" lIns="0" tIns="0" rIns="0" bIns="0" rtlCol="0" anchor="t"/>
+          <a:lstStyle/>
+          <a:p>
+            <a:pPr indent="0" marL="0">
+              <a:lnSpc>
+                <a:spcPct val="114000"/>
+              </a:lnSpc>
+              <a:buNone/>
+            </a:pPr>
+            <a:r>
+              <a:rPr lang="en-US" sz="1050" dirty="0">
+                <a:solidFill>
+                  <a:srgbClr val="E2E8F0"/>
+                </a:solidFill>
+                <a:latin typeface="Consolas" pitchFamily="34" charset="0"/>
+                <a:ea typeface="Consolas" pitchFamily="34" charset="-122"/>
+                <a:cs typeface="Consolas" pitchFamily="34" charset="-120"/>
+              </a:rPr>
+              <a:t>cd library/</a:t>
+            </a:r>
+            <a:endParaRPr lang="en-US" sz="1050" dirty="0"/>
+          </a:p>
+          <a:p>
+            <a:pPr indent="0" marL="0">
+              <a:lnSpc>
+                <a:spcPct val="114000"/>
+              </a:lnSpc>
+              <a:buNone/>
+            </a:pPr>
+            <a:r>
+              <a:rPr lang="en-US" sz="1050" dirty="0">
+                <a:solidFill>
+                  <a:srgbClr val="E2E8F0"/>
+                </a:solidFill>
+                <a:latin typeface="Consolas" pitchFamily="34" charset="0"/>
+                <a:ea typeface="Consolas" pitchFamily="34" charset="-122"/>
+                <a:cs typeface="Consolas" pitchFamily="34" charset="-120"/>
+              </a:rPr>
+              <a:t>git clone \</a:t>
+            </a:r>
+            <a:endParaRPr lang="en-US" sz="1050" dirty="0"/>
+          </a:p>
+          <a:p>
+            <a:pPr indent="0" marL="0">
+              <a:lnSpc>
+                <a:spcPct val="114000"/>
+              </a:lnSpc>
+              <a:buNone/>
+            </a:pPr>
+            <a:r>
+              <a:rPr lang="en-US" sz="1050" dirty="0">
+                <a:solidFill>
+                  <a:srgbClr val="E2E8F0"/>
+                </a:solidFill>
+                <a:latin typeface="Consolas" pitchFamily="34" charset="0"/>
+                <a:ea typeface="Consolas" pitchFamily="34" charset="-122"/>
+                <a:cs typeface="Consolas" pitchFamily="34" charset="-120"/>
+              </a:rPr>
+              <a:t>  https://github.com/NVIDIA/cutlass.git</a:t>
+            </a:r>
+            <a:endParaRPr lang="en-US" sz="1050" dirty="0"/>
+          </a:p>
+          <a:p>
+            <a:pPr indent="0" marL="0">
+              <a:lnSpc>
+                <a:spcPct val="114000"/>
+              </a:lnSpc>
+              <a:buNone/>
+            </a:pPr>
+            <a:r>
+              <a:rPr lang="en-US" sz="1050" dirty="0">
+                <a:solidFill>
+                  <a:srgbClr val="E2E8F0"/>
+                </a:solidFill>
+                <a:latin typeface="Consolas" pitchFamily="34" charset="0"/>
+                <a:ea typeface="Consolas" pitchFamily="34" charset="-122"/>
+                <a:cs typeface="Consolas" pitchFamily="34" charset="-120"/>
+              </a:rPr>
+              <a:t>cd retroinfer &amp;&amp; pip install . &amp;&amp; cd ..</a:t>
+            </a:r>
+            <a:endParaRPr lang="en-US" sz="1050" dirty="0"/>
+          </a:p>
+          <a:p>
+            <a:pPr indent="0" marL="0">
+              <a:lnSpc>
+                <a:spcPct val="114000"/>
+              </a:lnSpc>
+              <a:buNone/>
+            </a:pPr>
+            <a:endParaRPr lang="en-US" sz="1050" dirty="0"/>
+          </a:p>
+          <a:p>
+            <a:pPr indent="0" marL="0">
+              <a:lnSpc>
+                <a:spcPct val="114000"/>
+              </a:lnSpc>
+              <a:buNone/>
+            </a:pPr>
+            <a:r>
+              <a:rPr lang="en-US" sz="1050" dirty="0">
+                <a:solidFill>
+                  <a:srgbClr val="E2E8F0"/>
+                </a:solidFill>
+                <a:latin typeface="Consolas" pitchFamily="34" charset="0"/>
+                <a:ea typeface="Consolas" pitchFamily="34" charset="-122"/>
+                <a:cs typeface="Consolas" pitchFamily="34" charset="-120"/>
+              </a:rPr>
+              <a:t># 선택: MInference prefill</a:t>
+            </a:r>
+            <a:endParaRPr lang="en-US" sz="1050" dirty="0"/>
+          </a:p>
+          <a:p>
+            <a:pPr indent="0" marL="0">
+              <a:lnSpc>
+                <a:spcPct val="114000"/>
+              </a:lnSpc>
+              <a:buNone/>
+            </a:pPr>
+            <a:r>
+              <a:rPr lang="en-US" sz="1050" dirty="0">
+                <a:solidFill>
+                  <a:srgbClr val="E2E8F0"/>
+                </a:solidFill>
+                <a:latin typeface="Consolas" pitchFamily="34" charset="0"/>
+                <a:ea typeface="Consolas" pitchFamily="34" charset="-122"/>
+                <a:cs typeface="Consolas" pitchFamily="34" charset="-120"/>
+              </a:rPr>
+              <a:t>pip install minference==0.1.6.0</a:t>
+            </a:r>
+            <a:endParaRPr lang="en-US" sz="1050" dirty="0"/>
+          </a:p>
+          <a:p>
+            <a:pPr indent="0" marL="0">
+              <a:lnSpc>
+                <a:spcPct val="114000"/>
+              </a:lnSpc>
+              <a:buNone/>
+            </a:pPr>
+            <a:endParaRPr lang="en-US" sz="1050" dirty="0"/>
+          </a:p>
+          <a:p>
+            <a:pPr indent="0" marL="0">
+              <a:lnSpc>
+                <a:spcPct val="114000"/>
+              </a:lnSpc>
+              <a:buNone/>
+            </a:pPr>
+            <a:r>
+              <a:rPr lang="en-US" sz="1050" dirty="0">
+                <a:solidFill>
+                  <a:srgbClr val="E2E8F0"/>
+                </a:solidFill>
+                <a:latin typeface="Consolas" pitchFamily="34" charset="0"/>
+                <a:ea typeface="Consolas" pitchFamily="34" charset="-122"/>
+                <a:cs typeface="Consolas" pitchFamily="34" charset="-120"/>
+              </a:rPr>
+              <a:t># 선택: XAttention prefill</a:t>
+            </a:r>
+            <a:endParaRPr lang="en-US" sz="1050" dirty="0"/>
+          </a:p>
+          <a:p>
+            <a:pPr indent="0" marL="0">
+              <a:lnSpc>
+                <a:spcPct val="114000"/>
+              </a:lnSpc>
+              <a:buNone/>
+            </a:pPr>
+            <a:r>
+              <a:rPr lang="en-US" sz="1050" dirty="0">
+                <a:solidFill>
+                  <a:srgbClr val="E2E8F0"/>
+                </a:solidFill>
+                <a:latin typeface="Consolas" pitchFamily="34" charset="0"/>
+                <a:ea typeface="Consolas" pitchFamily="34" charset="-122"/>
+                <a:cs typeface="Consolas" pitchFamily="34" charset="-120"/>
+              </a:rPr>
+              <a:t>git clone .../Block-Sparse-Attention.git</a:t>
+            </a:r>
+            <a:endParaRPr lang="en-US" sz="1050" dirty="0"/>
+          </a:p>
+          <a:p>
+            <a:pPr indent="0" marL="0">
+              <a:lnSpc>
+                <a:spcPct val="114000"/>
+              </a:lnSpc>
+              <a:buNone/>
+            </a:pPr>
+            <a:r>
+              <a:rPr lang="en-US" sz="1050" dirty="0">
+                <a:solidFill>
+                  <a:srgbClr val="E2E8F0"/>
+                </a:solidFill>
+                <a:latin typeface="Consolas" pitchFamily="34" charset="0"/>
+                <a:ea typeface="Consolas" pitchFamily="34" charset="-122"/>
+                <a:cs typeface="Consolas" pitchFamily="34" charset="-120"/>
+              </a:rPr>
+              <a:t>cd Block-Sparse-Attention &amp;&amp; \</a:t>
+            </a:r>
+            <a:endParaRPr lang="en-US" sz="1050" dirty="0"/>
+          </a:p>
+          <a:p>
+            <a:pPr indent="0" marL="0">
+              <a:lnSpc>
+                <a:spcPct val="114000"/>
+              </a:lnSpc>
+              <a:buNone/>
+            </a:pPr>
+            <a:r>
+              <a:rPr lang="en-US" sz="1050" dirty="0">
+                <a:solidFill>
+                  <a:srgbClr val="E2E8F0"/>
+                </a:solidFill>
+                <a:latin typeface="Consolas" pitchFamily="34" charset="0"/>
+                <a:ea typeface="Consolas" pitchFamily="34" charset="-122"/>
+                <a:cs typeface="Consolas" pitchFamily="34" charset="-120"/>
+              </a:rPr>
+              <a:t>  python setup.py install</a:t>
+            </a:r>
+            <a:endParaRPr lang="en-US" sz="1050" dirty="0"/>
+          </a:p>
+        </p:txBody>
+      </p:sp>
+      <p:sp>
+        <p:nvSpPr>
+          <p:cNvPr id="10" name="Shape 8"/>
+          <p:cNvSpPr/>
+          <p:nvPr/>
+        </p:nvSpPr>
+        <p:spPr>
+          <a:xfrm>
+            <a:off x="548640" y="5212080"/>
+            <a:ext cx="11064240" cy="566928"/>
+          </a:xfrm>
+          <a:prstGeom prst="roundRect">
+            <a:avLst>
+              <a:gd name="adj" fmla="val 9677"/>
+            </a:avLst>
+          </a:prstGeom>
+          <a:solidFill>
+            <a:srgbClr val="FEF3E2"/>
+          </a:solidFill>
+          <a:ln w="12700">
+            <a:solidFill>
+              <a:srgbClr val="F59E0B"/>
+            </a:solidFill>
+            <a:prstDash val="solid"/>
+          </a:ln>
+        </p:spPr>
+      </p:sp>
+      <p:sp>
+        <p:nvSpPr>
+          <p:cNvPr id="11" name="Text 9"/>
+          <p:cNvSpPr/>
+          <p:nvPr/>
+        </p:nvSpPr>
+        <p:spPr>
+          <a:xfrm>
+            <a:off x="777240" y="5212080"/>
+            <a:ext cx="10607040" cy="566928"/>
+          </a:xfrm>
+          <a:prstGeom prst="rect">
+            <a:avLst/>
+          </a:prstGeom>
+          <a:noFill/>
+          <a:ln/>
+        </p:spPr>
+        <p:txBody>
+          <a:bodyPr wrap="square" lIns="0" tIns="0" rIns="0" bIns="0" rtlCol="0" anchor="ctr"/>
+          <a:lstStyle/>
+          <a:p>
+            <a:pPr indent="0" marL="0">
+              <a:buNone/>
+            </a:pPr>
+            <a:r>
+              <a:rPr lang="en-US" sz="1200" b="1" dirty="0">
+                <a:solidFill>
+                  <a:srgbClr val="92400E"/>
+                </a:solidFill>
+                <a:latin typeface="Malgun Gothic" pitchFamily="34" charset="0"/>
+                <a:ea typeface="Malgun Gothic" pitchFamily="34" charset="-122"/>
+                <a:cs typeface="Malgun Gothic" pitchFamily="34" charset="-120"/>
+              </a:rPr>
+              <a:t>TIP  </a:t>
+            </a:r>
+            <a:pPr indent="0" marL="0">
+              <a:buNone/>
+            </a:pPr>
+            <a:r>
+              <a:rPr lang="en-US" sz="1200" dirty="0">
+                <a:solidFill>
+                  <a:srgbClr val="5B4322"/>
+                </a:solidFill>
+                <a:latin typeface="Malgun Gothic" pitchFamily="34" charset="0"/>
+                <a:ea typeface="Malgun Gothic" pitchFamily="34" charset="-122"/>
+                <a:cs typeface="Malgun Gothic" pitchFamily="34" charset="-120"/>
+              </a:rPr>
+              <a:t>CUDA 12.4 미설치 시 도커 이미지 사용: nvidia/cuda:12.4.1-cudnn-devel-ubuntu22.04</a:t>
+            </a:r>
+            <a:endParaRPr lang="en-US" sz="1200" dirty="0"/>
+          </a:p>
+        </p:txBody>
+      </p:sp>
+      <p:sp>
+        <p:nvSpPr>
+          <p:cNvPr id="12" name="Text 10"/>
+          <p:cNvSpPr/>
+          <p:nvPr/>
+        </p:nvSpPr>
+        <p:spPr>
+          <a:xfrm>
+            <a:off x="457200" y="6400800"/>
+            <a:ext cx="5486400" cy="274320"/>
+          </a:xfrm>
+          <a:prstGeom prst="rect">
+            <a:avLst/>
+          </a:prstGeom>
+          <a:noFill/>
+          <a:ln/>
+        </p:spPr>
+        <p:txBody>
+          <a:bodyPr wrap="square" lIns="0" tIns="0" rIns="0" bIns="0" rtlCol="0" anchor="ctr"/>
+          <a:lstStyle/>
+          <a:p>
+            <a:pPr algn="l" indent="0" marL="0">
+              <a:buNone/>
+            </a:pPr>
+            <a:r>
+              <a:rPr lang="en-US" sz="1000" dirty="0">
+                <a:solidFill>
+                  <a:srgbClr val="64748B"/>
+                </a:solidFill>
+                <a:latin typeface="Malgun Gothic" pitchFamily="34" charset="0"/>
+                <a:ea typeface="Malgun Gothic" pitchFamily="34" charset="-122"/>
+                <a:cs typeface="Malgun Gothic" pitchFamily="34" charset="-120"/>
+              </a:rPr>
+              <a:t>RetroInfer · 기술 심화 세미나</a:t>
+            </a:r>
+            <a:endParaRPr lang="en-US" sz="1000" dirty="0"/>
+          </a:p>
+        </p:txBody>
+      </p:sp>
+      <p:sp>
+        <p:nvSpPr>
+          <p:cNvPr id="13" name="Text 11"/>
+          <p:cNvSpPr/>
+          <p:nvPr/>
+        </p:nvSpPr>
+        <p:spPr>
+          <a:xfrm>
+            <a:off x="11365992" y="6400800"/>
+            <a:ext cx="457200" cy="274320"/>
+          </a:xfrm>
+          <a:prstGeom prst="rect">
+            <a:avLst/>
+          </a:prstGeom>
+          <a:noFill/>
+          <a:ln/>
+        </p:spPr>
+        <p:txBody>
+          <a:bodyPr wrap="square" lIns="0" tIns="0" rIns="0" bIns="0" rtlCol="0" anchor="ctr"/>
+          <a:lstStyle/>
+          <a:p>
+            <a:pPr algn="r" indent="0" marL="0">
+              <a:buNone/>
+            </a:pPr>
+            <a:r>
+              <a:rPr lang="en-US" sz="1000" dirty="0">
+                <a:solidFill>
+                  <a:srgbClr val="64748B"/>
+                </a:solidFill>
+                <a:latin typeface="Malgun Gothic" pitchFamily="34" charset="0"/>
+                <a:ea typeface="Malgun Gothic" pitchFamily="34" charset="-122"/>
+                <a:cs typeface="Malgun Gothic" pitchFamily="34" charset="-120"/>
+              </a:rPr>
+              <a:t>12</a:t>
+            </a:r>
+            <a:endParaRPr lang="en-US" sz="1000" dirty="0"/>
+          </a:p>
+        </p:txBody>
+      </p:sp>
+    </p:spTree>
+  </p:cSld>
+  <p:clrMapOvr>
+    <a:masterClrMapping/>
+  </p:clrMapOvr>
+</p:sld>
+</file>
+
+<file path=ppt/slides/slide13.xml><?xml version="1.0" encoding="utf-8"?>
+<p:sld xmlns:a="http://schemas.openxmlformats.org/drawingml/2006/main" xmlns:r="http://schemas.openxmlformats.org/officeDocument/2006/relationships" xmlns:p="http://schemas.openxmlformats.org/presentationml/2006/main">
+  <p:cSld name="Slide 13">
+    <p:bg>
+      <p:bgPr>
+        <a:solidFill>
+          <a:srgbClr val="FFFFFF"/>
+        </a:solidFill>
+      </p:bgPr>
+    </p:bg>
+    <p:spTree>
+      <p:nvGrpSpPr>
+        <p:cNvPr id="1" name=""/>
+        <p:cNvGrpSpPr/>
+        <p:nvPr/>
+      </p:nvGrpSpPr>
+      <p:grpSpPr>
+        <a:xfrm>
+          <a:off x="0" y="0"/>
+          <a:ext cx="0" cy="0"/>
+          <a:chOff x="0" y="0"/>
+          <a:chExt cx="0" cy="0"/>
+        </a:xfrm>
+      </p:grpSpPr>
+      <p:sp>
+        <p:nvSpPr>
+          <p:cNvPr id="2" name="Text 0"/>
+          <p:cNvSpPr/>
+          <p:nvPr/>
+        </p:nvSpPr>
+        <p:spPr>
+          <a:xfrm>
+            <a:off x="548640" y="411480"/>
+            <a:ext cx="11091672" cy="640080"/>
+          </a:xfrm>
+          <a:prstGeom prst="rect">
+            <a:avLst/>
+          </a:prstGeom>
+          <a:noFill/>
+          <a:ln/>
+        </p:spPr>
+        <p:txBody>
+          <a:bodyPr wrap="square" lIns="0" tIns="0" rIns="0" bIns="0" rtlCol="0" anchor="ctr"/>
+          <a:lstStyle/>
+          <a:p>
+            <a:pPr indent="0" marL="0">
+              <a:buNone/>
+            </a:pPr>
+            <a:r>
+              <a:rPr lang="en-US" sz="3000" b="1" dirty="0">
+                <a:solidFill>
+                  <a:srgbClr val="0F172A"/>
+                </a:solidFill>
+                <a:latin typeface="Malgun Gothic" pitchFamily="34" charset="0"/>
+                <a:ea typeface="Malgun Gothic" pitchFamily="34" charset="-122"/>
+                <a:cs typeface="Malgun Gothic" pitchFamily="34" charset="-120"/>
+              </a:rPr>
+              <a:t>실전 ② 데모 실행 &amp; API</a:t>
+            </a:r>
+            <a:endParaRPr lang="en-US" sz="3000" dirty="0"/>
+          </a:p>
+        </p:txBody>
+      </p:sp>
+      <p:sp>
+        <p:nvSpPr>
+          <p:cNvPr id="3" name="Text 1"/>
+          <p:cNvSpPr/>
+          <p:nvPr/>
+        </p:nvSpPr>
+        <p:spPr>
+          <a:xfrm>
+            <a:off x="566928" y="1060704"/>
+            <a:ext cx="11091672" cy="365760"/>
+          </a:xfrm>
+          <a:prstGeom prst="rect">
+            <a:avLst/>
+          </a:prstGeom>
+          <a:noFill/>
+          <a:ln/>
+        </p:spPr>
+        <p:txBody>
+          <a:bodyPr wrap="square" lIns="0" tIns="0" rIns="0" bIns="0" rtlCol="0" anchor="ctr"/>
+          <a:lstStyle/>
+          <a:p>
+            <a:pPr indent="0" marL="0">
+              <a:buNone/>
+            </a:pPr>
+            <a:r>
+              <a:rPr lang="en-US" sz="1400" b="1" dirty="0">
+                <a:solidFill>
+                  <a:srgbClr val="14B8A6"/>
+                </a:solidFill>
+                <a:latin typeface="Malgun Gothic" pitchFamily="34" charset="0"/>
+                <a:ea typeface="Malgun Gothic" pitchFamily="34" charset="-122"/>
+                <a:cs typeface="Malgun Gothic" pitchFamily="34" charset="-120"/>
+              </a:rPr>
+              <a:t>환경 검증용 데모와 Python API 진입점</a:t>
+            </a:r>
+            <a:endParaRPr lang="en-US" sz="1400" dirty="0"/>
+          </a:p>
+        </p:txBody>
+      </p:sp>
+      <p:sp>
+        <p:nvSpPr>
+          <p:cNvPr id="4" name="Text 2"/>
+          <p:cNvSpPr/>
+          <p:nvPr/>
+        </p:nvSpPr>
+        <p:spPr>
+          <a:xfrm>
+            <a:off x="548640" y="1783080"/>
+            <a:ext cx="5486400" cy="329184"/>
+          </a:xfrm>
+          <a:prstGeom prst="rect">
+            <a:avLst/>
+          </a:prstGeom>
+          <a:noFill/>
+          <a:ln/>
+        </p:spPr>
+        <p:txBody>
+          <a:bodyPr wrap="square" lIns="0" tIns="0" rIns="0" bIns="0" rtlCol="0" anchor="ctr"/>
+          <a:lstStyle/>
+          <a:p>
+            <a:pPr indent="0" marL="0">
+              <a:buNone/>
+            </a:pPr>
+            <a:r>
+              <a:rPr lang="en-US" sz="1500" b="1" dirty="0">
+                <a:solidFill>
+                  <a:srgbClr val="0F766E"/>
+                </a:solidFill>
+                <a:latin typeface="Malgun Gothic" pitchFamily="34" charset="0"/>
+                <a:ea typeface="Malgun Gothic" pitchFamily="34" charset="-122"/>
+                <a:cs typeface="Malgun Gothic" pitchFamily="34" charset="-120"/>
+              </a:rPr>
+              <a:t>빠른 데모 — simple_test.py</a:t>
+            </a:r>
+            <a:endParaRPr lang="en-US" sz="1500" dirty="0"/>
+          </a:p>
+        </p:txBody>
+      </p:sp>
+      <p:sp>
+        <p:nvSpPr>
+          <p:cNvPr id="5" name="Shape 3"/>
+          <p:cNvSpPr/>
+          <p:nvPr/>
+        </p:nvSpPr>
+        <p:spPr>
+          <a:xfrm>
+            <a:off x="548640" y="2148840"/>
+            <a:ext cx="5486400" cy="1051560"/>
+          </a:xfrm>
+          <a:prstGeom prst="roundRect">
+            <a:avLst>
+              <a:gd name="adj" fmla="val 5217"/>
+            </a:avLst>
+          </a:prstGeom>
+          <a:solidFill>
+            <a:srgbClr val="0F172A"/>
+          </a:solidFill>
+          <a:ln/>
+        </p:spPr>
+      </p:sp>
+      <p:sp>
+        <p:nvSpPr>
+          <p:cNvPr id="6" name="Text 4"/>
+          <p:cNvSpPr/>
+          <p:nvPr/>
+        </p:nvSpPr>
+        <p:spPr>
+          <a:xfrm>
+            <a:off x="713232" y="2258568"/>
+            <a:ext cx="5157216" cy="832104"/>
+          </a:xfrm>
+          <a:prstGeom prst="rect">
+            <a:avLst/>
+          </a:prstGeom>
+          <a:noFill/>
+          <a:ln/>
+        </p:spPr>
+        <p:txBody>
+          <a:bodyPr wrap="square" lIns="0" tIns="0" rIns="0" bIns="0" rtlCol="0" anchor="t"/>
+          <a:lstStyle/>
+          <a:p>
+            <a:pPr indent="0" marL="0">
+              <a:lnSpc>
+                <a:spcPct val="114000"/>
+              </a:lnSpc>
+              <a:buNone/>
+            </a:pPr>
+            <a:r>
+              <a:rPr lang="en-US" sz="1200" dirty="0">
+                <a:solidFill>
+                  <a:srgbClr val="E2E8F0"/>
+                </a:solidFill>
+                <a:latin typeface="Consolas" pitchFamily="34" charset="0"/>
+                <a:ea typeface="Consolas" pitchFamily="34" charset="-122"/>
+                <a:cs typeface="Consolas" pitchFamily="34" charset="-120"/>
+              </a:rPr>
+              <a:t>python -u simple_test.py \</a:t>
+            </a:r>
+            <a:endParaRPr lang="en-US" sz="1200" dirty="0"/>
+          </a:p>
+          <a:p>
+            <a:pPr indent="0" marL="0">
+              <a:lnSpc>
+                <a:spcPct val="114000"/>
+              </a:lnSpc>
+              <a:buNone/>
+            </a:pPr>
+            <a:r>
+              <a:rPr lang="en-US" sz="1200" dirty="0">
+                <a:solidFill>
+                  <a:srgbClr val="E2E8F0"/>
+                </a:solidFill>
+                <a:latin typeface="Consolas" pitchFamily="34" charset="0"/>
+                <a:ea typeface="Consolas" pitchFamily="34" charset="-122"/>
+                <a:cs typeface="Consolas" pitchFamily="34" charset="-120"/>
+              </a:rPr>
+              <a:t>       --batch_size 4</a:t>
+            </a:r>
+            <a:endParaRPr lang="en-US" sz="1200" dirty="0"/>
+          </a:p>
+        </p:txBody>
+      </p:sp>
+      <p:sp>
+        <p:nvSpPr>
+          <p:cNvPr id="7" name="Text 5"/>
+          <p:cNvSpPr/>
+          <p:nvPr/>
+        </p:nvSpPr>
+        <p:spPr>
+          <a:xfrm>
+            <a:off x="566928" y="3310128"/>
+            <a:ext cx="5486400" cy="320040"/>
+          </a:xfrm>
+          <a:prstGeom prst="rect">
+            <a:avLst/>
+          </a:prstGeom>
+          <a:noFill/>
+          <a:ln/>
+        </p:spPr>
+        <p:txBody>
+          <a:bodyPr wrap="square" lIns="0" tIns="0" rIns="0" bIns="0" rtlCol="0" anchor="ctr"/>
+          <a:lstStyle/>
+          <a:p>
+            <a:pPr indent="0" marL="0">
+              <a:buNone/>
+            </a:pPr>
+            <a:r>
+              <a:rPr lang="en-US" sz="1200" b="1" dirty="0">
+                <a:solidFill>
+                  <a:srgbClr val="0F172A"/>
+                </a:solidFill>
+                <a:latin typeface="Malgun Gothic" pitchFamily="34" charset="0"/>
+                <a:ea typeface="Malgun Gothic" pitchFamily="34" charset="-122"/>
+                <a:cs typeface="Malgun Gothic" pitchFamily="34" charset="-120"/>
+              </a:rPr>
+              <a:t>메모리: </a:t>
+            </a:r>
+            <a:pPr indent="0" marL="0">
+              <a:buNone/>
+            </a:pPr>
+            <a:r>
+              <a:rPr lang="en-US" sz="1200" dirty="0">
+                <a:solidFill>
+                  <a:srgbClr val="334155"/>
+                </a:solidFill>
+                <a:latin typeface="Malgun Gothic" pitchFamily="34" charset="0"/>
+                <a:ea typeface="Malgun Gothic" pitchFamily="34" charset="-122"/>
+                <a:cs typeface="Malgun Gothic" pitchFamily="34" charset="-120"/>
+              </a:rPr>
+              <a:t>약 35GB GPU + 70GB CPU (batch 4)</a:t>
+            </a:r>
+            <a:endParaRPr lang="en-US" sz="1200" dirty="0"/>
+          </a:p>
+        </p:txBody>
+      </p:sp>
+      <p:sp>
+        <p:nvSpPr>
+          <p:cNvPr id="8" name="Text 6"/>
+          <p:cNvSpPr/>
+          <p:nvPr/>
+        </p:nvSpPr>
+        <p:spPr>
+          <a:xfrm>
+            <a:off x="640080" y="3703320"/>
+            <a:ext cx="5394960" cy="329184"/>
+          </a:xfrm>
+          <a:prstGeom prst="rect">
+            <a:avLst/>
+          </a:prstGeom>
+          <a:noFill/>
+          <a:ln/>
+        </p:spPr>
+        <p:txBody>
+          <a:bodyPr wrap="square" lIns="0" tIns="0" rIns="0" bIns="0" rtlCol="0" anchor="ctr"/>
+          <a:lstStyle/>
+          <a:p>
+            <a:pPr indent="0" marL="0">
+              <a:buNone/>
+            </a:pPr>
+            <a:r>
+              <a:rPr lang="en-US" sz="1200" b="1" dirty="0">
+                <a:solidFill>
+                  <a:srgbClr val="0F766E"/>
+                </a:solidFill>
+                <a:latin typeface="Consolas" pitchFamily="34" charset="0"/>
+                <a:ea typeface="Consolas" pitchFamily="34" charset="-122"/>
+                <a:cs typeface="Consolas" pitchFamily="34" charset="-120"/>
+              </a:rPr>
+              <a:t>--gpu_only  </a:t>
+            </a:r>
+            <a:pPr indent="0" marL="0">
+              <a:buNone/>
+            </a:pPr>
+            <a:r>
+              <a:rPr lang="en-US" sz="1200" dirty="0">
+                <a:solidFill>
+                  <a:srgbClr val="334155"/>
+                </a:solidFill>
+                <a:latin typeface="Malgun Gothic" pitchFamily="34" charset="0"/>
+                <a:ea typeface="Malgun Gothic" pitchFamily="34" charset="-122"/>
+                <a:cs typeface="Malgun Gothic" pitchFamily="34" charset="-120"/>
+              </a:rPr>
+              <a:t>전체 KV를 GPU에 상주</a:t>
+            </a:r>
+            <a:endParaRPr lang="en-US" sz="1200" dirty="0"/>
+          </a:p>
+        </p:txBody>
+      </p:sp>
+      <p:sp>
+        <p:nvSpPr>
+          <p:cNvPr id="9" name="Text 7"/>
+          <p:cNvSpPr/>
+          <p:nvPr/>
+        </p:nvSpPr>
+        <p:spPr>
+          <a:xfrm>
+            <a:off x="640080" y="4160520"/>
+            <a:ext cx="5394960" cy="329184"/>
+          </a:xfrm>
+          <a:prstGeom prst="rect">
+            <a:avLst/>
+          </a:prstGeom>
+          <a:noFill/>
+          <a:ln/>
+        </p:spPr>
+        <p:txBody>
+          <a:bodyPr wrap="square" lIns="0" tIns="0" rIns="0" bIns="0" rtlCol="0" anchor="ctr"/>
+          <a:lstStyle/>
+          <a:p>
+            <a:pPr indent="0" marL="0">
+              <a:buNone/>
+            </a:pPr>
+            <a:r>
+              <a:rPr lang="en-US" sz="1200" b="1" dirty="0">
+                <a:solidFill>
+                  <a:srgbClr val="0F766E"/>
+                </a:solidFill>
+                <a:latin typeface="Consolas" pitchFamily="34" charset="0"/>
+                <a:ea typeface="Consolas" pitchFamily="34" charset="-122"/>
+                <a:cs typeface="Consolas" pitchFamily="34" charset="-120"/>
+              </a:rPr>
+              <a:t>--use_cuda_graph  </a:t>
+            </a:r>
+            <a:pPr indent="0" marL="0">
+              <a:buNone/>
+            </a:pPr>
+            <a:r>
+              <a:rPr lang="en-US" sz="1200" dirty="0">
+                <a:solidFill>
+                  <a:srgbClr val="334155"/>
+                </a:solidFill>
+                <a:latin typeface="Malgun Gothic" pitchFamily="34" charset="0"/>
+                <a:ea typeface="Malgun Gothic" pitchFamily="34" charset="-122"/>
+                <a:cs typeface="Malgun Gothic" pitchFamily="34" charset="-120"/>
+              </a:rPr>
+              <a:t>CUDA Graph로 런치 오버헤드 감소</a:t>
+            </a:r>
+            <a:endParaRPr lang="en-US" sz="1200" dirty="0"/>
+          </a:p>
+        </p:txBody>
+      </p:sp>
+      <p:sp>
+        <p:nvSpPr>
+          <p:cNvPr id="10" name="Text 8"/>
+          <p:cNvSpPr/>
+          <p:nvPr/>
+        </p:nvSpPr>
+        <p:spPr>
+          <a:xfrm>
+            <a:off x="640080" y="4617720"/>
+            <a:ext cx="5394960" cy="329184"/>
+          </a:xfrm>
+          <a:prstGeom prst="rect">
+            <a:avLst/>
+          </a:prstGeom>
+          <a:noFill/>
+          <a:ln/>
+        </p:spPr>
+        <p:txBody>
+          <a:bodyPr wrap="square" lIns="0" tIns="0" rIns="0" bIns="0" rtlCol="0" anchor="ctr"/>
+          <a:lstStyle/>
+          <a:p>
+            <a:pPr indent="0" marL="0">
+              <a:buNone/>
+            </a:pPr>
+            <a:r>
+              <a:rPr lang="en-US" sz="1200" b="1" dirty="0">
+                <a:solidFill>
+                  <a:srgbClr val="0F766E"/>
+                </a:solidFill>
+                <a:latin typeface="Consolas" pitchFamily="34" charset="0"/>
+                <a:ea typeface="Consolas" pitchFamily="34" charset="-122"/>
+                <a:cs typeface="Consolas" pitchFamily="34" charset="-120"/>
+              </a:rPr>
+              <a:t>--do_sample  </a:t>
+            </a:r>
+            <a:pPr indent="0" marL="0">
+              <a:buNone/>
+            </a:pPr>
+            <a:r>
+              <a:rPr lang="en-US" sz="1200" dirty="0">
+                <a:solidFill>
+                  <a:srgbClr val="334155"/>
+                </a:solidFill>
+                <a:latin typeface="Malgun Gothic" pitchFamily="34" charset="0"/>
+                <a:ea typeface="Malgun Gothic" pitchFamily="34" charset="-122"/>
+                <a:cs typeface="Malgun Gothic" pitchFamily="34" charset="-120"/>
+              </a:rPr>
+              <a:t>샘플링 디코딩</a:t>
+            </a:r>
+            <a:endParaRPr lang="en-US" sz="1200" dirty="0"/>
+          </a:p>
+        </p:txBody>
+      </p:sp>
+      <p:sp>
+        <p:nvSpPr>
+          <p:cNvPr id="11" name="Text 9"/>
+          <p:cNvSpPr/>
+          <p:nvPr/>
+        </p:nvSpPr>
+        <p:spPr>
+          <a:xfrm>
+            <a:off x="640080" y="5074920"/>
+            <a:ext cx="5394960" cy="329184"/>
+          </a:xfrm>
+          <a:prstGeom prst="rect">
+            <a:avLst/>
+          </a:prstGeom>
+          <a:noFill/>
+          <a:ln/>
+        </p:spPr>
+        <p:txBody>
+          <a:bodyPr wrap="square" lIns="0" tIns="0" rIns="0" bIns="0" rtlCol="0" anchor="ctr"/>
+          <a:lstStyle/>
+          <a:p>
+            <a:pPr indent="0" marL="0">
+              <a:buNone/>
+            </a:pPr>
+            <a:r>
+              <a:rPr lang="en-US" sz="1200" b="1" dirty="0">
+                <a:solidFill>
+                  <a:srgbClr val="0F766E"/>
+                </a:solidFill>
+                <a:latin typeface="Consolas" pitchFamily="34" charset="0"/>
+                <a:ea typeface="Consolas" pitchFamily="34" charset="-122"/>
+                <a:cs typeface="Consolas" pitchFamily="34" charset="-120"/>
+              </a:rPr>
+              <a:t>--prefill_method  </a:t>
+            </a:r>
+            <a:pPr indent="0" marL="0">
+              <a:buNone/>
+            </a:pPr>
+            <a:r>
+              <a:rPr lang="en-US" sz="1200" dirty="0">
+                <a:solidFill>
+                  <a:srgbClr val="334155"/>
+                </a:solidFill>
+                <a:latin typeface="Malgun Gothic" pitchFamily="34" charset="0"/>
+                <a:ea typeface="Malgun Gothic" pitchFamily="34" charset="-122"/>
+                <a:cs typeface="Malgun Gothic" pitchFamily="34" charset="-120"/>
+              </a:rPr>
+              <a:t>full / xattn / minfer</a:t>
+            </a:r>
+            <a:endParaRPr lang="en-US" sz="1200" dirty="0"/>
+          </a:p>
+        </p:txBody>
+      </p:sp>
+      <p:sp>
+        <p:nvSpPr>
+          <p:cNvPr id="12" name="Text 10"/>
+          <p:cNvSpPr/>
+          <p:nvPr/>
+        </p:nvSpPr>
+        <p:spPr>
+          <a:xfrm>
+            <a:off x="6309360" y="1783080"/>
+            <a:ext cx="5303520" cy="329184"/>
+          </a:xfrm>
+          <a:prstGeom prst="rect">
+            <a:avLst/>
+          </a:prstGeom>
+          <a:noFill/>
+          <a:ln/>
+        </p:spPr>
+        <p:txBody>
+          <a:bodyPr wrap="square" lIns="0" tIns="0" rIns="0" bIns="0" rtlCol="0" anchor="ctr"/>
+          <a:lstStyle/>
+          <a:p>
+            <a:pPr indent="0" marL="0">
+              <a:buNone/>
+            </a:pPr>
+            <a:r>
+              <a:rPr lang="en-US" sz="1500" b="1" dirty="0">
+                <a:solidFill>
+                  <a:srgbClr val="1E3A8A"/>
+                </a:solidFill>
+                <a:latin typeface="Malgun Gothic" pitchFamily="34" charset="0"/>
+                <a:ea typeface="Malgun Gothic" pitchFamily="34" charset="-122"/>
+                <a:cs typeface="Malgun Gothic" pitchFamily="34" charset="-120"/>
+              </a:rPr>
+              <a:t>Python API</a:t>
+            </a:r>
+            <a:endParaRPr lang="en-US" sz="1500" dirty="0"/>
+          </a:p>
+        </p:txBody>
+      </p:sp>
+      <p:sp>
+        <p:nvSpPr>
+          <p:cNvPr id="13" name="Shape 11"/>
+          <p:cNvSpPr/>
+          <p:nvPr/>
+        </p:nvSpPr>
+        <p:spPr>
+          <a:xfrm>
+            <a:off x="6309360" y="2148840"/>
+            <a:ext cx="5303520" cy="3611880"/>
+          </a:xfrm>
+          <a:prstGeom prst="roundRect">
+            <a:avLst>
+              <a:gd name="adj" fmla="val 1519"/>
+            </a:avLst>
+          </a:prstGeom>
+          <a:solidFill>
+            <a:srgbClr val="0F172A"/>
+          </a:solidFill>
+          <a:ln/>
+        </p:spPr>
+      </p:sp>
+      <p:sp>
+        <p:nvSpPr>
+          <p:cNvPr id="14" name="Text 12"/>
+          <p:cNvSpPr/>
+          <p:nvPr/>
+        </p:nvSpPr>
+        <p:spPr>
+          <a:xfrm>
+            <a:off x="6473952" y="2258568"/>
+            <a:ext cx="4974336" cy="3392424"/>
+          </a:xfrm>
+          <a:prstGeom prst="rect">
+            <a:avLst/>
+          </a:prstGeom>
+          <a:noFill/>
+          <a:ln/>
+        </p:spPr>
+        <p:txBody>
+          <a:bodyPr wrap="square" lIns="0" tIns="0" rIns="0" bIns="0" rtlCol="0" anchor="t"/>
+          <a:lstStyle/>
+          <a:p>
+            <a:pPr indent="0" marL="0">
+              <a:lnSpc>
+                <a:spcPct val="114000"/>
+              </a:lnSpc>
+              <a:buNone/>
+            </a:pPr>
+            <a:r>
+              <a:rPr lang="en-US" sz="1050" dirty="0">
+                <a:solidFill>
+                  <a:srgbClr val="E2E8F0"/>
+                </a:solidFill>
+                <a:latin typeface="Consolas" pitchFamily="34" charset="0"/>
+                <a:ea typeface="Consolas" pitchFamily="34" charset="-122"/>
+                <a:cs typeface="Consolas" pitchFamily="34" charset="-120"/>
+              </a:rPr>
+              <a:t>from model_hub import load_model, \</a:t>
+            </a:r>
+            <a:endParaRPr lang="en-US" sz="1050" dirty="0"/>
+          </a:p>
+          <a:p>
+            <a:pPr indent="0" marL="0">
+              <a:lnSpc>
+                <a:spcPct val="114000"/>
+              </a:lnSpc>
+              <a:buNone/>
+            </a:pPr>
+            <a:r>
+              <a:rPr lang="en-US" sz="1050" dirty="0">
+                <a:solidFill>
+                  <a:srgbClr val="E2E8F0"/>
+                </a:solidFill>
+                <a:latin typeface="Consolas" pitchFamily="34" charset="0"/>
+                <a:ea typeface="Consolas" pitchFamily="34" charset="-122"/>
+                <a:cs typeface="Consolas" pitchFamily="34" charset="-120"/>
+              </a:rPr>
+              <a:t>     load_tokenizer</a:t>
+            </a:r>
+            <a:endParaRPr lang="en-US" sz="1050" dirty="0"/>
+          </a:p>
+          <a:p>
+            <a:pPr indent="0" marL="0">
+              <a:lnSpc>
+                <a:spcPct val="114000"/>
+              </a:lnSpc>
+              <a:buNone/>
+            </a:pPr>
+            <a:r>
+              <a:rPr lang="en-US" sz="1050" dirty="0">
+                <a:solidFill>
+                  <a:srgbClr val="E2E8F0"/>
+                </a:solidFill>
+                <a:latin typeface="Consolas" pitchFamily="34" charset="0"/>
+                <a:ea typeface="Consolas" pitchFamily="34" charset="-122"/>
+                <a:cs typeface="Consolas" pitchFamily="34" charset="-120"/>
+              </a:rPr>
+              <a:t>from config import generate_config</a:t>
+            </a:r>
+            <a:endParaRPr lang="en-US" sz="1050" dirty="0"/>
+          </a:p>
+          <a:p>
+            <a:pPr indent="0" marL="0">
+              <a:lnSpc>
+                <a:spcPct val="114000"/>
+              </a:lnSpc>
+              <a:buNone/>
+            </a:pPr>
+            <a:endParaRPr lang="en-US" sz="1050" dirty="0"/>
+          </a:p>
+          <a:p>
+            <a:pPr indent="0" marL="0">
+              <a:lnSpc>
+                <a:spcPct val="114000"/>
+              </a:lnSpc>
+              <a:buNone/>
+            </a:pPr>
+            <a:r>
+              <a:rPr lang="en-US" sz="1050" dirty="0">
+                <a:solidFill>
+                  <a:srgbClr val="E2E8F0"/>
+                </a:solidFill>
+                <a:latin typeface="Consolas" pitchFamily="34" charset="0"/>
+                <a:ea typeface="Consolas" pitchFamily="34" charset="-122"/>
+                <a:cs typeface="Consolas" pitchFamily="34" charset="-120"/>
+              </a:rPr>
+              <a:t>tokenizer = load_tokenizer(model_name)</a:t>
+            </a:r>
+            <a:endParaRPr lang="en-US" sz="1050" dirty="0"/>
+          </a:p>
+          <a:p>
+            <a:pPr indent="0" marL="0">
+              <a:lnSpc>
+                <a:spcPct val="114000"/>
+              </a:lnSpc>
+              <a:buNone/>
+            </a:pPr>
+            <a:r>
+              <a:rPr lang="en-US" sz="1050" dirty="0">
+                <a:solidFill>
+                  <a:srgbClr val="E2E8F0"/>
+                </a:solidFill>
+                <a:latin typeface="Consolas" pitchFamily="34" charset="0"/>
+                <a:ea typeface="Consolas" pitchFamily="34" charset="-122"/>
+                <a:cs typeface="Consolas" pitchFamily="34" charset="-120"/>
+              </a:rPr>
+              <a:t>llm = load_model(model_name, max_seq_len,</a:t>
+            </a:r>
+            <a:endParaRPr lang="en-US" sz="1050" dirty="0"/>
+          </a:p>
+          <a:p>
+            <a:pPr indent="0" marL="0">
+              <a:lnSpc>
+                <a:spcPct val="114000"/>
+              </a:lnSpc>
+              <a:buNone/>
+            </a:pPr>
+            <a:r>
+              <a:rPr lang="en-US" sz="1050" dirty="0">
+                <a:solidFill>
+                  <a:srgbClr val="E2E8F0"/>
+                </a:solidFill>
+                <a:latin typeface="Consolas" pitchFamily="34" charset="0"/>
+                <a:ea typeface="Consolas" pitchFamily="34" charset="-122"/>
+                <a:cs typeface="Consolas" pitchFamily="34" charset="-120"/>
+              </a:rPr>
+              <a:t>                 dtype, device, tokenizer)</a:t>
+            </a:r>
+            <a:endParaRPr lang="en-US" sz="1050" dirty="0"/>
+          </a:p>
+          <a:p>
+            <a:pPr indent="0" marL="0">
+              <a:lnSpc>
+                <a:spcPct val="114000"/>
+              </a:lnSpc>
+              <a:buNone/>
+            </a:pPr>
+            <a:endParaRPr lang="en-US" sz="1050" dirty="0"/>
+          </a:p>
+          <a:p>
+            <a:pPr indent="0" marL="0">
+              <a:lnSpc>
+                <a:spcPct val="114000"/>
+              </a:lnSpc>
+              <a:buNone/>
+            </a:pPr>
+            <a:r>
+              <a:rPr lang="en-US" sz="1050" dirty="0">
+                <a:solidFill>
+                  <a:srgbClr val="E2E8F0"/>
+                </a:solidFill>
+                <a:latin typeface="Consolas" pitchFamily="34" charset="0"/>
+                <a:ea typeface="Consolas" pitchFamily="34" charset="-122"/>
+                <a:cs typeface="Consolas" pitchFamily="34" charset="-120"/>
+              </a:rPr>
+              <a:t>attn_config = generate_config(</a:t>
+            </a:r>
+            <a:endParaRPr lang="en-US" sz="1050" dirty="0"/>
+          </a:p>
+          <a:p>
+            <a:pPr indent="0" marL="0">
+              <a:lnSpc>
+                <a:spcPct val="114000"/>
+              </a:lnSpc>
+              <a:buNone/>
+            </a:pPr>
+            <a:r>
+              <a:rPr lang="en-US" sz="1050" dirty="0">
+                <a:solidFill>
+                  <a:srgbClr val="E2E8F0"/>
+                </a:solidFill>
+                <a:latin typeface="Consolas" pitchFamily="34" charset="0"/>
+                <a:ea typeface="Consolas" pitchFamily="34" charset="-122"/>
+                <a:cs typeface="Consolas" pitchFamily="34" charset="-120"/>
+              </a:rPr>
+              <a:t>    model_name, input_seq_len, "RetroInfer",</a:t>
+            </a:r>
+            <a:endParaRPr lang="en-US" sz="1050" dirty="0"/>
+          </a:p>
+          <a:p>
+            <a:pPr indent="0" marL="0">
+              <a:lnSpc>
+                <a:spcPct val="114000"/>
+              </a:lnSpc>
+              <a:buNone/>
+            </a:pPr>
+            <a:r>
+              <a:rPr lang="en-US" sz="1050" dirty="0">
+                <a:solidFill>
+                  <a:srgbClr val="E2E8F0"/>
+                </a:solidFill>
+                <a:latin typeface="Consolas" pitchFamily="34" charset="0"/>
+                <a:ea typeface="Consolas" pitchFamily="34" charset="-122"/>
+                <a:cs typeface="Consolas" pitchFamily="34" charset="-120"/>
+              </a:rPr>
+              <a:t>    retrieval_budget, estimation_budget,</a:t>
+            </a:r>
+            <a:endParaRPr lang="en-US" sz="1050" dirty="0"/>
+          </a:p>
+          <a:p>
+            <a:pPr indent="0" marL="0">
+              <a:lnSpc>
+                <a:spcPct val="114000"/>
+              </a:lnSpc>
+              <a:buNone/>
+            </a:pPr>
+            <a:r>
+              <a:rPr lang="en-US" sz="1050" dirty="0">
+                <a:solidFill>
+                  <a:srgbClr val="E2E8F0"/>
+                </a:solidFill>
+                <a:latin typeface="Consolas" pitchFamily="34" charset="0"/>
+                <a:ea typeface="Consolas" pitchFamily="34" charset="-122"/>
+                <a:cs typeface="Consolas" pitchFamily="34" charset="-120"/>
+              </a:rPr>
+              <a:t>    cache_ratio)</a:t>
+            </a:r>
+            <a:endParaRPr lang="en-US" sz="1050" dirty="0"/>
+          </a:p>
+          <a:p>
+            <a:pPr indent="0" marL="0">
+              <a:lnSpc>
+                <a:spcPct val="114000"/>
+              </a:lnSpc>
+              <a:buNone/>
+            </a:pPr>
+            <a:endParaRPr lang="en-US" sz="1050" dirty="0"/>
+          </a:p>
+          <a:p>
+            <a:pPr indent="0" marL="0">
+              <a:lnSpc>
+                <a:spcPct val="114000"/>
+              </a:lnSpc>
+              <a:buNone/>
+            </a:pPr>
+            <a:r>
+              <a:rPr lang="en-US" sz="1050" dirty="0">
+                <a:solidFill>
+                  <a:srgbClr val="E2E8F0"/>
+                </a:solidFill>
+                <a:latin typeface="Consolas" pitchFamily="34" charset="0"/>
+                <a:ea typeface="Consolas" pitchFamily="34" charset="-122"/>
+                <a:cs typeface="Consolas" pitchFamily="34" charset="-120"/>
+              </a:rPr>
+              <a:t>out = llm.generate(</a:t>
+            </a:r>
+            <a:endParaRPr lang="en-US" sz="1050" dirty="0"/>
+          </a:p>
+          <a:p>
+            <a:pPr indent="0" marL="0">
+              <a:lnSpc>
+                <a:spcPct val="114000"/>
+              </a:lnSpc>
+              <a:buNone/>
+            </a:pPr>
+            <a:r>
+              <a:rPr lang="en-US" sz="1050" dirty="0">
+                <a:solidFill>
+                  <a:srgbClr val="E2E8F0"/>
+                </a:solidFill>
+                <a:latin typeface="Consolas" pitchFamily="34" charset="0"/>
+                <a:ea typeface="Consolas" pitchFamily="34" charset="-122"/>
+                <a:cs typeface="Consolas" pitchFamily="34" charset="-120"/>
+              </a:rPr>
+              <a:t>    attention_type=attn_type,</a:t>
+            </a:r>
+            <a:endParaRPr lang="en-US" sz="1050" dirty="0"/>
+          </a:p>
+          <a:p>
+            <a:pPr indent="0" marL="0">
+              <a:lnSpc>
+                <a:spcPct val="114000"/>
+              </a:lnSpc>
+              <a:buNone/>
+            </a:pPr>
+            <a:r>
+              <a:rPr lang="en-US" sz="1050" dirty="0">
+                <a:solidFill>
+                  <a:srgbClr val="E2E8F0"/>
+                </a:solidFill>
+                <a:latin typeface="Consolas" pitchFamily="34" charset="0"/>
+                <a:ea typeface="Consolas" pitchFamily="34" charset="-122"/>
+                <a:cs typeface="Consolas" pitchFamily="34" charset="-120"/>
+              </a:rPr>
+              <a:t>    inputs_ids=input_ids, ...,</a:t>
+            </a:r>
+            <a:endParaRPr lang="en-US" sz="1050" dirty="0"/>
+          </a:p>
+          <a:p>
+            <a:pPr indent="0" marL="0">
+              <a:lnSpc>
+                <a:spcPct val="114000"/>
+              </a:lnSpc>
+              <a:buNone/>
+            </a:pPr>
+            <a:r>
+              <a:rPr lang="en-US" sz="1050" dirty="0">
+                <a:solidFill>
+                  <a:srgbClr val="E2E8F0"/>
+                </a:solidFill>
+                <a:latin typeface="Consolas" pitchFamily="34" charset="0"/>
+                <a:ea typeface="Consolas" pitchFamily="34" charset="-122"/>
+                <a:cs typeface="Consolas" pitchFamily="34" charset="-120"/>
+              </a:rPr>
+              <a:t>    attn_config=attn_config)</a:t>
+            </a:r>
+            <a:endParaRPr lang="en-US" sz="1050" dirty="0"/>
+          </a:p>
+        </p:txBody>
+      </p:sp>
+      <p:sp>
+        <p:nvSpPr>
+          <p:cNvPr id="15" name="Text 13"/>
+          <p:cNvSpPr/>
+          <p:nvPr/>
+        </p:nvSpPr>
+        <p:spPr>
+          <a:xfrm>
+            <a:off x="457200" y="6400800"/>
+            <a:ext cx="5486400" cy="274320"/>
+          </a:xfrm>
+          <a:prstGeom prst="rect">
+            <a:avLst/>
+          </a:prstGeom>
+          <a:noFill/>
+          <a:ln/>
+        </p:spPr>
+        <p:txBody>
+          <a:bodyPr wrap="square" lIns="0" tIns="0" rIns="0" bIns="0" rtlCol="0" anchor="ctr"/>
+          <a:lstStyle/>
+          <a:p>
+            <a:pPr algn="l" indent="0" marL="0">
+              <a:buNone/>
+            </a:pPr>
+            <a:r>
+              <a:rPr lang="en-US" sz="1000" dirty="0">
+                <a:solidFill>
+                  <a:srgbClr val="64748B"/>
+                </a:solidFill>
+                <a:latin typeface="Malgun Gothic" pitchFamily="34" charset="0"/>
+                <a:ea typeface="Malgun Gothic" pitchFamily="34" charset="-122"/>
+                <a:cs typeface="Malgun Gothic" pitchFamily="34" charset="-120"/>
+              </a:rPr>
+              <a:t>RetroInfer · 기술 심화 세미나</a:t>
+            </a:r>
+            <a:endParaRPr lang="en-US" sz="1000" dirty="0"/>
+          </a:p>
+        </p:txBody>
+      </p:sp>
+      <p:sp>
+        <p:nvSpPr>
+          <p:cNvPr id="16" name="Text 14"/>
+          <p:cNvSpPr/>
+          <p:nvPr/>
+        </p:nvSpPr>
+        <p:spPr>
+          <a:xfrm>
+            <a:off x="11365992" y="6400800"/>
+            <a:ext cx="457200" cy="274320"/>
+          </a:xfrm>
+          <a:prstGeom prst="rect">
+            <a:avLst/>
+          </a:prstGeom>
+          <a:noFill/>
+          <a:ln/>
+        </p:spPr>
+        <p:txBody>
+          <a:bodyPr wrap="square" lIns="0" tIns="0" rIns="0" bIns="0" rtlCol="0" anchor="ctr"/>
+          <a:lstStyle/>
+          <a:p>
+            <a:pPr algn="r" indent="0" marL="0">
+              <a:buNone/>
+            </a:pPr>
+            <a:r>
+              <a:rPr lang="en-US" sz="1000" dirty="0">
+                <a:solidFill>
+                  <a:srgbClr val="64748B"/>
+                </a:solidFill>
+                <a:latin typeface="Malgun Gothic" pitchFamily="34" charset="0"/>
+                <a:ea typeface="Malgun Gothic" pitchFamily="34" charset="-122"/>
+                <a:cs typeface="Malgun Gothic" pitchFamily="34" charset="-120"/>
+              </a:rPr>
+              <a:t>13</a:t>
+            </a:r>
+            <a:endParaRPr lang="en-US" sz="1000" dirty="0"/>
+          </a:p>
+        </p:txBody>
+      </p:sp>
+    </p:spTree>
+  </p:cSld>
+  <p:clrMapOvr>
+    <a:masterClrMapping/>
+  </p:clrMapOvr>
+</p:sld>
+</file>
+
+<file path=ppt/slides/slide14.xml><?xml version="1.0" encoding="utf-8"?>
+<p:sld xmlns:a="http://schemas.openxmlformats.org/drawingml/2006/main" xmlns:r="http://schemas.openxmlformats.org/officeDocument/2006/relationships" xmlns:p="http://schemas.openxmlformats.org/presentationml/2006/main">
+  <p:cSld name="Slide 14">
+    <p:bg>
+      <p:bgPr>
+        <a:solidFill>
+          <a:srgbClr val="FFFFFF"/>
+        </a:solidFill>
+      </p:bgPr>
+    </p:bg>
+    <p:spTree>
+      <p:nvGrpSpPr>
+        <p:cNvPr id="1" name=""/>
+        <p:cNvGrpSpPr/>
+        <p:nvPr/>
+      </p:nvGrpSpPr>
+      <p:grpSpPr>
+        <a:xfrm>
+          <a:off x="0" y="0"/>
+          <a:ext cx="0" cy="0"/>
+          <a:chOff x="0" y="0"/>
+          <a:chExt cx="0" cy="0"/>
+        </a:xfrm>
+      </p:grpSpPr>
+      <p:sp>
+        <p:nvSpPr>
+          <p:cNvPr id="2" name="Text 0"/>
+          <p:cNvSpPr/>
+          <p:nvPr/>
+        </p:nvSpPr>
+        <p:spPr>
+          <a:xfrm>
+            <a:off x="548640" y="411480"/>
+            <a:ext cx="11091672" cy="640080"/>
+          </a:xfrm>
+          <a:prstGeom prst="rect">
+            <a:avLst/>
+          </a:prstGeom>
+          <a:noFill/>
+          <a:ln/>
+        </p:spPr>
+        <p:txBody>
+          <a:bodyPr wrap="square" lIns="0" tIns="0" rIns="0" bIns="0" rtlCol="0" anchor="ctr"/>
+          <a:lstStyle/>
+          <a:p>
+            <a:pPr indent="0" marL="0">
+              <a:buNone/>
+            </a:pPr>
+            <a:r>
+              <a:rPr lang="en-US" sz="3000" b="1" dirty="0">
+                <a:solidFill>
+                  <a:srgbClr val="0F172A"/>
+                </a:solidFill>
+                <a:latin typeface="Malgun Gothic" pitchFamily="34" charset="0"/>
+                <a:ea typeface="Malgun Gothic" pitchFamily="34" charset="-122"/>
+                <a:cs typeface="Malgun Gothic" pitchFamily="34" charset="-120"/>
+              </a:rPr>
+              <a:t>실전 ③ 정확도 벤치마크</a:t>
+            </a:r>
+            <a:endParaRPr lang="en-US" sz="3000" dirty="0"/>
+          </a:p>
+        </p:txBody>
+      </p:sp>
+      <p:sp>
+        <p:nvSpPr>
+          <p:cNvPr id="3" name="Text 1"/>
+          <p:cNvSpPr/>
+          <p:nvPr/>
+        </p:nvSpPr>
+        <p:spPr>
+          <a:xfrm>
+            <a:off x="566928" y="1060704"/>
+            <a:ext cx="11091672" cy="365760"/>
+          </a:xfrm>
+          <a:prstGeom prst="rect">
+            <a:avLst/>
+          </a:prstGeom>
+          <a:noFill/>
+          <a:ln/>
+        </p:spPr>
+        <p:txBody>
+          <a:bodyPr wrap="square" lIns="0" tIns="0" rIns="0" bIns="0" rtlCol="0" anchor="ctr"/>
+          <a:lstStyle/>
+          <a:p>
+            <a:pPr indent="0" marL="0">
+              <a:buNone/>
+            </a:pPr>
+            <a:r>
+              <a:rPr lang="en-US" sz="1400" b="1" dirty="0">
+                <a:solidFill>
+                  <a:srgbClr val="14B8A6"/>
+                </a:solidFill>
+                <a:latin typeface="Malgun Gothic" pitchFamily="34" charset="0"/>
+                <a:ea typeface="Malgun Gothic" pitchFamily="34" charset="-122"/>
+                <a:cs typeface="Malgun Gothic" pitchFamily="34" charset="-120"/>
+              </a:rPr>
+              <a:t>긴 컨텍스트 표준 벤치마크로 정확도 검증</a:t>
+            </a:r>
+            <a:endParaRPr lang="en-US" sz="1400" dirty="0"/>
+          </a:p>
+        </p:txBody>
+      </p:sp>
+      <p:sp>
+        <p:nvSpPr>
+          <p:cNvPr id="4" name="Shape 2"/>
+          <p:cNvSpPr/>
+          <p:nvPr/>
+        </p:nvSpPr>
+        <p:spPr>
+          <a:xfrm>
+            <a:off x="548640" y="1783080"/>
+            <a:ext cx="3520440" cy="3977640"/>
+          </a:xfrm>
+          <a:prstGeom prst="roundRect">
+            <a:avLst>
+              <a:gd name="adj" fmla="val 2597"/>
+            </a:avLst>
+          </a:prstGeom>
+          <a:solidFill>
+            <a:srgbClr val="F1F5F9"/>
+          </a:solidFill>
+          <a:ln w="12700">
+            <a:solidFill>
+              <a:srgbClr val="CBD5E1"/>
+            </a:solidFill>
+            <a:prstDash val="solid"/>
+          </a:ln>
+        </p:spPr>
+      </p:sp>
+      <p:sp>
+        <p:nvSpPr>
+          <p:cNvPr id="5" name="Shape 3"/>
+          <p:cNvSpPr/>
+          <p:nvPr/>
+        </p:nvSpPr>
+        <p:spPr>
+          <a:xfrm>
+            <a:off x="548640" y="1783080"/>
+            <a:ext cx="3520440" cy="566928"/>
+          </a:xfrm>
+          <a:prstGeom prst="roundRect">
+            <a:avLst>
+              <a:gd name="adj" fmla="val 16129"/>
+            </a:avLst>
+          </a:prstGeom>
+          <a:solidFill>
+            <a:srgbClr val="8B5CF6"/>
+          </a:solidFill>
+          <a:ln/>
+        </p:spPr>
+      </p:sp>
+      <p:sp>
+        <p:nvSpPr>
+          <p:cNvPr id="6" name="Shape 4"/>
+          <p:cNvSpPr/>
+          <p:nvPr/>
+        </p:nvSpPr>
+        <p:spPr>
+          <a:xfrm>
+            <a:off x="548640" y="2148840"/>
+            <a:ext cx="3520440" cy="201168"/>
+          </a:xfrm>
+          <a:prstGeom prst="rect">
+            <a:avLst/>
+          </a:prstGeom>
+          <a:solidFill>
+            <a:srgbClr val="8B5CF6"/>
+          </a:solidFill>
+          <a:ln/>
+        </p:spPr>
+      </p:sp>
+      <p:sp>
+        <p:nvSpPr>
+          <p:cNvPr id="7" name="Text 5"/>
+          <p:cNvSpPr/>
+          <p:nvPr/>
+        </p:nvSpPr>
+        <p:spPr>
+          <a:xfrm>
+            <a:off x="777240" y="1783080"/>
+            <a:ext cx="3063240" cy="566928"/>
+          </a:xfrm>
+          <a:prstGeom prst="rect">
+            <a:avLst/>
+          </a:prstGeom>
+          <a:noFill/>
+          <a:ln/>
+        </p:spPr>
+        <p:txBody>
+          <a:bodyPr wrap="square" lIns="0" tIns="0" rIns="0" bIns="0" rtlCol="0" anchor="ctr"/>
+          <a:lstStyle/>
+          <a:p>
+            <a:pPr indent="0" marL="0">
+              <a:buNone/>
+            </a:pPr>
+            <a:r>
+              <a:rPr lang="en-US" sz="1700" b="1" dirty="0">
+                <a:solidFill>
+                  <a:srgbClr val="FFFFFF"/>
+                </a:solidFill>
+                <a:latin typeface="Malgun Gothic" pitchFamily="34" charset="0"/>
+                <a:ea typeface="Malgun Gothic" pitchFamily="34" charset="-122"/>
+                <a:cs typeface="Malgun Gothic" pitchFamily="34" charset="-120"/>
+              </a:rPr>
+              <a:t>RULER</a:t>
+            </a:r>
+            <a:endParaRPr lang="en-US" sz="1700" dirty="0"/>
+          </a:p>
+        </p:txBody>
+      </p:sp>
+      <p:sp>
+        <p:nvSpPr>
+          <p:cNvPr id="8" name="Shape 6"/>
+          <p:cNvSpPr/>
+          <p:nvPr/>
+        </p:nvSpPr>
+        <p:spPr>
+          <a:xfrm>
+            <a:off x="749808" y="2514600"/>
+            <a:ext cx="3108960" cy="1783080"/>
+          </a:xfrm>
+          <a:prstGeom prst="roundRect">
+            <a:avLst>
+              <a:gd name="adj" fmla="val 3077"/>
+            </a:avLst>
+          </a:prstGeom>
+          <a:solidFill>
+            <a:srgbClr val="0F172A"/>
+          </a:solidFill>
+          <a:ln/>
+        </p:spPr>
+      </p:sp>
+      <p:sp>
+        <p:nvSpPr>
+          <p:cNvPr id="9" name="Text 7"/>
+          <p:cNvSpPr/>
+          <p:nvPr/>
+        </p:nvSpPr>
+        <p:spPr>
+          <a:xfrm>
+            <a:off x="914400" y="2624328"/>
+            <a:ext cx="2779776" cy="1563624"/>
+          </a:xfrm>
+          <a:prstGeom prst="rect">
+            <a:avLst/>
+          </a:prstGeom>
+          <a:noFill/>
+          <a:ln/>
+        </p:spPr>
+        <p:txBody>
+          <a:bodyPr wrap="square" lIns="0" tIns="0" rIns="0" bIns="0" rtlCol="0" anchor="t"/>
+          <a:lstStyle/>
+          <a:p>
+            <a:pPr indent="0" marL="0">
+              <a:lnSpc>
+                <a:spcPct val="114000"/>
+              </a:lnSpc>
+              <a:buNone/>
+            </a:pPr>
+            <a:r>
+              <a:rPr lang="en-US" sz="900" dirty="0">
+                <a:solidFill>
+                  <a:srgbClr val="E2E8F0"/>
+                </a:solidFill>
+                <a:latin typeface="Consolas" pitchFamily="34" charset="0"/>
+                <a:ea typeface="Consolas" pitchFamily="34" charset="-122"/>
+                <a:cs typeface="Consolas" pitchFamily="34" charset="-120"/>
+              </a:rPr>
+              <a:t>bash ruler_run.sh llama-3-8b-1048k \</a:t>
+            </a:r>
+            <a:endParaRPr lang="en-US" sz="900" dirty="0"/>
+          </a:p>
+          <a:p>
+            <a:pPr indent="0" marL="0">
+              <a:lnSpc>
+                <a:spcPct val="114000"/>
+              </a:lnSpc>
+              <a:buNone/>
+            </a:pPr>
+            <a:r>
+              <a:rPr lang="en-US" sz="900" dirty="0">
+                <a:solidFill>
+                  <a:srgbClr val="E2E8F0"/>
+                </a:solidFill>
+                <a:latin typeface="Consolas" pitchFamily="34" charset="0"/>
+                <a:ea typeface="Consolas" pitchFamily="34" charset="-122"/>
+                <a:cs typeface="Consolas" pitchFamily="34" charset="-120"/>
+              </a:rPr>
+              <a:t>  full RetroInfer 131072 vt bf16 \</a:t>
+            </a:r>
+            <a:endParaRPr lang="en-US" sz="900" dirty="0"/>
+          </a:p>
+          <a:p>
+            <a:pPr indent="0" marL="0">
+              <a:lnSpc>
+                <a:spcPct val="114000"/>
+              </a:lnSpc>
+              <a:buNone/>
+            </a:pPr>
+            <a:r>
+              <a:rPr lang="en-US" sz="900" dirty="0">
+                <a:solidFill>
+                  <a:srgbClr val="E2E8F0"/>
+                </a:solidFill>
+                <a:latin typeface="Consolas" pitchFamily="34" charset="0"/>
+                <a:ea typeface="Consolas" pitchFamily="34" charset="-122"/>
+                <a:cs typeface="Consolas" pitchFamily="34" charset="-120"/>
+              </a:rPr>
+              <a:t>  0.018 0.232</a:t>
+            </a:r>
+            <a:endParaRPr lang="en-US" sz="900" dirty="0"/>
+          </a:p>
+        </p:txBody>
+      </p:sp>
+      <p:sp>
+        <p:nvSpPr>
+          <p:cNvPr id="10" name="Text 8"/>
+          <p:cNvSpPr/>
+          <p:nvPr/>
+        </p:nvSpPr>
+        <p:spPr>
+          <a:xfrm>
+            <a:off x="777240" y="4434840"/>
+            <a:ext cx="3108960" cy="1188720"/>
+          </a:xfrm>
+          <a:prstGeom prst="rect">
+            <a:avLst/>
+          </a:prstGeom>
+          <a:noFill/>
+          <a:ln/>
+        </p:spPr>
+        <p:txBody>
+          <a:bodyPr wrap="square" lIns="0" tIns="0" rIns="0" bIns="0" rtlCol="0" anchor="ctr"/>
+          <a:lstStyle/>
+          <a:p>
+            <a:pPr indent="0" marL="0">
+              <a:lnSpc>
+                <a:spcPct val="110000"/>
+              </a:lnSpc>
+              <a:buNone/>
+            </a:pPr>
+            <a:r>
+              <a:rPr lang="en-US" sz="1100" dirty="0">
+                <a:solidFill>
+                  <a:srgbClr val="334155"/>
+                </a:solidFill>
+                <a:latin typeface="Malgun Gothic" pitchFamily="34" charset="0"/>
+                <a:ea typeface="Malgun Gothic" pitchFamily="34" charset="-122"/>
+                <a:cs typeface="Malgun Gothic" pitchFamily="34" charset="-120"/>
+              </a:rPr>
+              <a:t>128K 컨텍스트 · NIAH/VT/CWE/FWE/QA</a:t>
+            </a:r>
+            <a:endParaRPr lang="en-US" sz="1100" dirty="0"/>
+          </a:p>
+          <a:p>
+            <a:pPr indent="0" marL="0">
+              <a:lnSpc>
+                <a:spcPct val="110000"/>
+              </a:lnSpc>
+              <a:buNone/>
+            </a:pPr>
+            <a:r>
+              <a:rPr lang="en-US" sz="1100" dirty="0">
+                <a:solidFill>
+                  <a:srgbClr val="334155"/>
+                </a:solidFill>
+                <a:latin typeface="Malgun Gothic" pitchFamily="34" charset="0"/>
+                <a:ea typeface="Malgun Gothic" pitchFamily="34" charset="-122"/>
+                <a:cs typeface="Malgun Gothic" pitchFamily="34" charset="-120"/>
+              </a:rPr>
+              <a:t>인자: 모델·prefill·attn·길이·태스크·dtype·budget</a:t>
+            </a:r>
+            <a:endParaRPr lang="en-US" sz="1100" dirty="0"/>
+          </a:p>
+        </p:txBody>
+      </p:sp>
+      <p:sp>
+        <p:nvSpPr>
+          <p:cNvPr id="11" name="Shape 9"/>
+          <p:cNvSpPr/>
+          <p:nvPr/>
+        </p:nvSpPr>
+        <p:spPr>
+          <a:xfrm>
+            <a:off x="4343400" y="1783080"/>
+            <a:ext cx="3520440" cy="3977640"/>
+          </a:xfrm>
+          <a:prstGeom prst="roundRect">
+            <a:avLst>
+              <a:gd name="adj" fmla="val 2597"/>
+            </a:avLst>
+          </a:prstGeom>
+          <a:solidFill>
+            <a:srgbClr val="F1F5F9"/>
+          </a:solidFill>
+          <a:ln w="12700">
+            <a:solidFill>
+              <a:srgbClr val="CBD5E1"/>
+            </a:solidFill>
+            <a:prstDash val="solid"/>
+          </a:ln>
+        </p:spPr>
+      </p:sp>
+      <p:sp>
+        <p:nvSpPr>
+          <p:cNvPr id="12" name="Shape 10"/>
+          <p:cNvSpPr/>
+          <p:nvPr/>
+        </p:nvSpPr>
+        <p:spPr>
+          <a:xfrm>
+            <a:off x="4343400" y="1783080"/>
+            <a:ext cx="3520440" cy="566928"/>
+          </a:xfrm>
+          <a:prstGeom prst="roundRect">
+            <a:avLst>
+              <a:gd name="adj" fmla="val 16129"/>
+            </a:avLst>
+          </a:prstGeom>
+          <a:solidFill>
+            <a:srgbClr val="14B8A6"/>
+          </a:solidFill>
+          <a:ln/>
+        </p:spPr>
+      </p:sp>
+      <p:sp>
+        <p:nvSpPr>
+          <p:cNvPr id="13" name="Shape 11"/>
+          <p:cNvSpPr/>
+          <p:nvPr/>
+        </p:nvSpPr>
+        <p:spPr>
+          <a:xfrm>
+            <a:off x="4343400" y="2148840"/>
+            <a:ext cx="3520440" cy="201168"/>
+          </a:xfrm>
+          <a:prstGeom prst="rect">
+            <a:avLst/>
+          </a:prstGeom>
+          <a:solidFill>
+            <a:srgbClr val="14B8A6"/>
+          </a:solidFill>
+          <a:ln/>
+        </p:spPr>
+      </p:sp>
+      <p:sp>
+        <p:nvSpPr>
+          <p:cNvPr id="14" name="Text 12"/>
+          <p:cNvSpPr/>
+          <p:nvPr/>
+        </p:nvSpPr>
+        <p:spPr>
+          <a:xfrm>
+            <a:off x="4572000" y="1783080"/>
+            <a:ext cx="3063240" cy="566928"/>
+          </a:xfrm>
+          <a:prstGeom prst="rect">
+            <a:avLst/>
+          </a:prstGeom>
+          <a:noFill/>
+          <a:ln/>
+        </p:spPr>
+        <p:txBody>
+          <a:bodyPr wrap="square" lIns="0" tIns="0" rIns="0" bIns="0" rtlCol="0" anchor="ctr"/>
+          <a:lstStyle/>
+          <a:p>
+            <a:pPr indent="0" marL="0">
+              <a:buNone/>
+            </a:pPr>
+            <a:r>
+              <a:rPr lang="en-US" sz="1700" b="1" dirty="0">
+                <a:solidFill>
+                  <a:srgbClr val="FFFFFF"/>
+                </a:solidFill>
+                <a:latin typeface="Malgun Gothic" pitchFamily="34" charset="0"/>
+                <a:ea typeface="Malgun Gothic" pitchFamily="34" charset="-122"/>
+                <a:cs typeface="Malgun Gothic" pitchFamily="34" charset="-120"/>
+              </a:rPr>
+              <a:t>LongBench</a:t>
+            </a:r>
+            <a:endParaRPr lang="en-US" sz="1700" dirty="0"/>
+          </a:p>
+        </p:txBody>
+      </p:sp>
+      <p:sp>
+        <p:nvSpPr>
+          <p:cNvPr id="15" name="Shape 13"/>
+          <p:cNvSpPr/>
+          <p:nvPr/>
+        </p:nvSpPr>
+        <p:spPr>
+          <a:xfrm>
+            <a:off x="4544568" y="2514600"/>
+            <a:ext cx="3108960" cy="1783080"/>
+          </a:xfrm>
+          <a:prstGeom prst="roundRect">
+            <a:avLst>
+              <a:gd name="adj" fmla="val 3077"/>
+            </a:avLst>
+          </a:prstGeom>
+          <a:solidFill>
+            <a:srgbClr val="0F172A"/>
+          </a:solidFill>
+          <a:ln/>
+        </p:spPr>
+      </p:sp>
+      <p:sp>
+        <p:nvSpPr>
+          <p:cNvPr id="16" name="Text 14"/>
+          <p:cNvSpPr/>
+          <p:nvPr/>
+        </p:nvSpPr>
+        <p:spPr>
+          <a:xfrm>
+            <a:off x="4709160" y="2624328"/>
+            <a:ext cx="2779776" cy="1563624"/>
+          </a:xfrm>
+          <a:prstGeom prst="rect">
+            <a:avLst/>
+          </a:prstGeom>
+          <a:noFill/>
+          <a:ln/>
+        </p:spPr>
+        <p:txBody>
+          <a:bodyPr wrap="square" lIns="0" tIns="0" rIns="0" bIns="0" rtlCol="0" anchor="t"/>
+          <a:lstStyle/>
+          <a:p>
+            <a:pPr indent="0" marL="0">
+              <a:lnSpc>
+                <a:spcPct val="114000"/>
+              </a:lnSpc>
+              <a:buNone/>
+            </a:pPr>
+            <a:r>
+              <a:rPr lang="en-US" sz="900" dirty="0">
+                <a:solidFill>
+                  <a:srgbClr val="E2E8F0"/>
+                </a:solidFill>
+                <a:latin typeface="Consolas" pitchFamily="34" charset="0"/>
+                <a:ea typeface="Consolas" pitchFamily="34" charset="-122"/>
+                <a:cs typeface="Consolas" pitchFamily="34" charset="-120"/>
+              </a:rPr>
+              <a:t>bash longbench_run.sh \</a:t>
+            </a:r>
+            <a:endParaRPr lang="en-US" sz="900" dirty="0"/>
+          </a:p>
+          <a:p>
+            <a:pPr indent="0" marL="0">
+              <a:lnSpc>
+                <a:spcPct val="114000"/>
+              </a:lnSpc>
+              <a:buNone/>
+            </a:pPr>
+            <a:r>
+              <a:rPr lang="en-US" sz="900" dirty="0">
+                <a:solidFill>
+                  <a:srgbClr val="E2E8F0"/>
+                </a:solidFill>
+                <a:latin typeface="Consolas" pitchFamily="34" charset="0"/>
+                <a:ea typeface="Consolas" pitchFamily="34" charset="-122"/>
+                <a:cs typeface="Consolas" pitchFamily="34" charset="-120"/>
+              </a:rPr>
+              <a:t>  llama-3-8b-1048k RetroInfer \</a:t>
+            </a:r>
+            <a:endParaRPr lang="en-US" sz="900" dirty="0"/>
+          </a:p>
+          <a:p>
+            <a:pPr indent="0" marL="0">
+              <a:lnSpc>
+                <a:spcPct val="114000"/>
+              </a:lnSpc>
+              <a:buNone/>
+            </a:pPr>
+            <a:r>
+              <a:rPr lang="en-US" sz="900" dirty="0">
+                <a:solidFill>
+                  <a:srgbClr val="E2E8F0"/>
+                </a:solidFill>
+                <a:latin typeface="Consolas" pitchFamily="34" charset="0"/>
+                <a:ea typeface="Consolas" pitchFamily="34" charset="-122"/>
+                <a:cs typeface="Consolas" pitchFamily="34" charset="-120"/>
+              </a:rPr>
+              <a:t>  0.018 0.232 bf16 SQA</a:t>
+            </a:r>
+            <a:endParaRPr lang="en-US" sz="900" dirty="0"/>
+          </a:p>
+        </p:txBody>
+      </p:sp>
+      <p:sp>
+        <p:nvSpPr>
+          <p:cNvPr id="17" name="Text 15"/>
+          <p:cNvSpPr/>
+          <p:nvPr/>
+        </p:nvSpPr>
+        <p:spPr>
+          <a:xfrm>
+            <a:off x="4572000" y="4434840"/>
+            <a:ext cx="3108960" cy="1188720"/>
+          </a:xfrm>
+          <a:prstGeom prst="rect">
+            <a:avLst/>
+          </a:prstGeom>
+          <a:noFill/>
+          <a:ln/>
+        </p:spPr>
+        <p:txBody>
+          <a:bodyPr wrap="square" lIns="0" tIns="0" rIns="0" bIns="0" rtlCol="0" anchor="ctr"/>
+          <a:lstStyle/>
+          <a:p>
+            <a:pPr indent="0" marL="0">
+              <a:lnSpc>
+                <a:spcPct val="110000"/>
+              </a:lnSpc>
+              <a:buNone/>
+            </a:pPr>
+            <a:r>
+              <a:rPr lang="en-US" sz="1100" dirty="0">
+                <a:solidFill>
+                  <a:srgbClr val="334155"/>
+                </a:solidFill>
+                <a:latin typeface="Malgun Gothic" pitchFamily="34" charset="0"/>
+                <a:ea typeface="Malgun Gothic" pitchFamily="34" charset="-122"/>
+                <a:cs typeface="Malgun Gothic" pitchFamily="34" charset="-120"/>
+              </a:rPr>
+              <a:t>SQA·MQA·SUM·FSL·ST·CC 범주</a:t>
+            </a:r>
+            <a:endParaRPr lang="en-US" sz="1100" dirty="0"/>
+          </a:p>
+          <a:p>
+            <a:pPr indent="0" marL="0">
+              <a:lnSpc>
+                <a:spcPct val="110000"/>
+              </a:lnSpc>
+              <a:buNone/>
+            </a:pPr>
+            <a:r>
+              <a:rPr lang="en-US" sz="1100" dirty="0">
+                <a:solidFill>
+                  <a:srgbClr val="334155"/>
+                </a:solidFill>
+                <a:latin typeface="Malgun Gothic" pitchFamily="34" charset="0"/>
+                <a:ea typeface="Malgun Gothic" pitchFamily="34" charset="-122"/>
+                <a:cs typeface="Malgun Gothic" pitchFamily="34" charset="-120"/>
+              </a:rPr>
+              <a:t>인자: 모델·attn·budget·dtype·범주</a:t>
+            </a:r>
+            <a:endParaRPr lang="en-US" sz="1100" dirty="0"/>
+          </a:p>
+        </p:txBody>
+      </p:sp>
+      <p:sp>
+        <p:nvSpPr>
+          <p:cNvPr id="18" name="Shape 16"/>
+          <p:cNvSpPr/>
+          <p:nvPr/>
+        </p:nvSpPr>
+        <p:spPr>
+          <a:xfrm>
+            <a:off x="8138160" y="1783080"/>
+            <a:ext cx="3520440" cy="3977640"/>
+          </a:xfrm>
+          <a:prstGeom prst="roundRect">
+            <a:avLst>
+              <a:gd name="adj" fmla="val 2597"/>
+            </a:avLst>
+          </a:prstGeom>
+          <a:solidFill>
+            <a:srgbClr val="F1F5F9"/>
+          </a:solidFill>
+          <a:ln w="12700">
+            <a:solidFill>
+              <a:srgbClr val="CBD5E1"/>
+            </a:solidFill>
+            <a:prstDash val="solid"/>
+          </a:ln>
+        </p:spPr>
+      </p:sp>
+      <p:sp>
+        <p:nvSpPr>
+          <p:cNvPr id="19" name="Shape 17"/>
+          <p:cNvSpPr/>
+          <p:nvPr/>
+        </p:nvSpPr>
+        <p:spPr>
+          <a:xfrm>
+            <a:off x="8138160" y="1783080"/>
+            <a:ext cx="3520440" cy="566928"/>
+          </a:xfrm>
+          <a:prstGeom prst="roundRect">
+            <a:avLst>
+              <a:gd name="adj" fmla="val 16129"/>
+            </a:avLst>
+          </a:prstGeom>
+          <a:solidFill>
+            <a:srgbClr val="F59E0B"/>
+          </a:solidFill>
+          <a:ln/>
+        </p:spPr>
+      </p:sp>
+      <p:sp>
+        <p:nvSpPr>
+          <p:cNvPr id="20" name="Shape 18"/>
+          <p:cNvSpPr/>
+          <p:nvPr/>
+        </p:nvSpPr>
+        <p:spPr>
+          <a:xfrm>
+            <a:off x="8138160" y="2148840"/>
+            <a:ext cx="3520440" cy="201168"/>
+          </a:xfrm>
+          <a:prstGeom prst="rect">
+            <a:avLst/>
+          </a:prstGeom>
+          <a:solidFill>
+            <a:srgbClr val="F59E0B"/>
+          </a:solidFill>
+          <a:ln/>
+        </p:spPr>
+      </p:sp>
+      <p:sp>
+        <p:nvSpPr>
+          <p:cNvPr id="21" name="Text 19"/>
+          <p:cNvSpPr/>
+          <p:nvPr/>
+        </p:nvSpPr>
+        <p:spPr>
+          <a:xfrm>
+            <a:off x="8366760" y="1783080"/>
+            <a:ext cx="3063240" cy="566928"/>
+          </a:xfrm>
+          <a:prstGeom prst="rect">
+            <a:avLst/>
+          </a:prstGeom>
+          <a:noFill/>
+          <a:ln/>
+        </p:spPr>
+        <p:txBody>
+          <a:bodyPr wrap="square" lIns="0" tIns="0" rIns="0" bIns="0" rtlCol="0" anchor="ctr"/>
+          <a:lstStyle/>
+          <a:p>
+            <a:pPr indent="0" marL="0">
+              <a:buNone/>
+            </a:pPr>
+            <a:r>
+              <a:rPr lang="en-US" sz="1700" b="1" dirty="0">
+                <a:solidFill>
+                  <a:srgbClr val="FFFFFF"/>
+                </a:solidFill>
+                <a:latin typeface="Malgun Gothic" pitchFamily="34" charset="0"/>
+                <a:ea typeface="Malgun Gothic" pitchFamily="34" charset="-122"/>
+                <a:cs typeface="Malgun Gothic" pitchFamily="34" charset="-120"/>
+              </a:rPr>
+              <a:t>Reasoning</a:t>
+            </a:r>
+            <a:endParaRPr lang="en-US" sz="1700" dirty="0"/>
+          </a:p>
+        </p:txBody>
+      </p:sp>
+      <p:sp>
+        <p:nvSpPr>
+          <p:cNvPr id="22" name="Shape 20"/>
+          <p:cNvSpPr/>
+          <p:nvPr/>
+        </p:nvSpPr>
+        <p:spPr>
+          <a:xfrm>
+            <a:off x="8339328" y="2514600"/>
+            <a:ext cx="3108960" cy="1783080"/>
+          </a:xfrm>
+          <a:prstGeom prst="roundRect">
+            <a:avLst>
+              <a:gd name="adj" fmla="val 3077"/>
+            </a:avLst>
+          </a:prstGeom>
+          <a:solidFill>
+            <a:srgbClr val="0F172A"/>
+          </a:solidFill>
+          <a:ln/>
+        </p:spPr>
+      </p:sp>
+      <p:sp>
+        <p:nvSpPr>
+          <p:cNvPr id="23" name="Text 21"/>
+          <p:cNvSpPr/>
+          <p:nvPr/>
+        </p:nvSpPr>
+        <p:spPr>
+          <a:xfrm>
+            <a:off x="8503920" y="2624328"/>
+            <a:ext cx="2779776" cy="1563624"/>
+          </a:xfrm>
+          <a:prstGeom prst="rect">
+            <a:avLst/>
+          </a:prstGeom>
+          <a:noFill/>
+          <a:ln/>
+        </p:spPr>
+        <p:txBody>
+          <a:bodyPr wrap="square" lIns="0" tIns="0" rIns="0" bIns="0" rtlCol="0" anchor="t"/>
+          <a:lstStyle/>
+          <a:p>
+            <a:pPr indent="0" marL="0">
+              <a:lnSpc>
+                <a:spcPct val="114000"/>
+              </a:lnSpc>
+              <a:buNone/>
+            </a:pPr>
+            <a:r>
+              <a:rPr lang="en-US" sz="900" dirty="0">
+                <a:solidFill>
+                  <a:srgbClr val="E2E8F0"/>
+                </a:solidFill>
+                <a:latin typeface="Consolas" pitchFamily="34" charset="0"/>
+                <a:ea typeface="Consolas" pitchFamily="34" charset="-122"/>
+                <a:cs typeface="Consolas" pitchFamily="34" charset="-120"/>
+              </a:rPr>
+              <a:t>bash eval.sh \</a:t>
+            </a:r>
+            <a:endParaRPr lang="en-US" sz="900" dirty="0"/>
+          </a:p>
+          <a:p>
+            <a:pPr indent="0" marL="0">
+              <a:lnSpc>
+                <a:spcPct val="114000"/>
+              </a:lnSpc>
+              <a:buNone/>
+            </a:pPr>
+            <a:r>
+              <a:rPr lang="en-US" sz="900" dirty="0">
+                <a:solidFill>
+                  <a:srgbClr val="E2E8F0"/>
+                </a:solidFill>
+                <a:latin typeface="Consolas" pitchFamily="34" charset="0"/>
+                <a:ea typeface="Consolas" pitchFamily="34" charset="-122"/>
+                <a:cs typeface="Consolas" pitchFamily="34" charset="-120"/>
+              </a:rPr>
+              <a:t>  deepseek-ai/DeepSeek-R1-\</a:t>
+            </a:r>
+            <a:endParaRPr lang="en-US" sz="900" dirty="0"/>
+          </a:p>
+          <a:p>
+            <a:pPr indent="0" marL="0">
+              <a:lnSpc>
+                <a:spcPct val="114000"/>
+              </a:lnSpc>
+              <a:buNone/>
+            </a:pPr>
+            <a:r>
+              <a:rPr lang="en-US" sz="900" dirty="0">
+                <a:solidFill>
+                  <a:srgbClr val="E2E8F0"/>
+                </a:solidFill>
+                <a:latin typeface="Consolas" pitchFamily="34" charset="0"/>
+                <a:ea typeface="Consolas" pitchFamily="34" charset="-122"/>
+                <a:cs typeface="Consolas" pitchFamily="34" charset="-120"/>
+              </a:rPr>
+              <a:t>  Distill-Llama-8B RetroInfer \</a:t>
+            </a:r>
+            <a:endParaRPr lang="en-US" sz="900" dirty="0"/>
+          </a:p>
+          <a:p>
+            <a:pPr indent="0" marL="0">
+              <a:lnSpc>
+                <a:spcPct val="114000"/>
+              </a:lnSpc>
+              <a:buNone/>
+            </a:pPr>
+            <a:r>
+              <a:rPr lang="en-US" sz="900" dirty="0">
+                <a:solidFill>
+                  <a:srgbClr val="E2E8F0"/>
+                </a:solidFill>
+                <a:latin typeface="Consolas" pitchFamily="34" charset="0"/>
+                <a:ea typeface="Consolas" pitchFamily="34" charset="-122"/>
+                <a:cs typeface="Consolas" pitchFamily="34" charset="-120"/>
+              </a:rPr>
+              <a:t>  aime24 0 -1</a:t>
+            </a:r>
+            <a:endParaRPr lang="en-US" sz="900" dirty="0"/>
+          </a:p>
+        </p:txBody>
+      </p:sp>
+      <p:sp>
+        <p:nvSpPr>
+          <p:cNvPr id="24" name="Text 22"/>
+          <p:cNvSpPr/>
+          <p:nvPr/>
+        </p:nvSpPr>
+        <p:spPr>
+          <a:xfrm>
+            <a:off x="8366760" y="4434840"/>
+            <a:ext cx="3108960" cy="1188720"/>
+          </a:xfrm>
+          <a:prstGeom prst="rect">
+            <a:avLst/>
+          </a:prstGeom>
+          <a:noFill/>
+          <a:ln/>
+        </p:spPr>
+        <p:txBody>
+          <a:bodyPr wrap="square" lIns="0" tIns="0" rIns="0" bIns="0" rtlCol="0" anchor="ctr"/>
+          <a:lstStyle/>
+          <a:p>
+            <a:pPr indent="0" marL="0">
+              <a:lnSpc>
+                <a:spcPct val="110000"/>
+              </a:lnSpc>
+              <a:buNone/>
+            </a:pPr>
+            <a:r>
+              <a:rPr lang="en-US" sz="1100" dirty="0">
+                <a:solidFill>
+                  <a:srgbClr val="334155"/>
+                </a:solidFill>
+                <a:latin typeface="Malgun Gothic" pitchFamily="34" charset="0"/>
+                <a:ea typeface="Malgun Gothic" pitchFamily="34" charset="-122"/>
+                <a:cs typeface="Malgun Gothic" pitchFamily="34" charset="-120"/>
+              </a:rPr>
+              <a:t>AIME / GPQA 장문 추론 (pass@k)</a:t>
+            </a:r>
+            <a:endParaRPr lang="en-US" sz="1100" dirty="0"/>
+          </a:p>
+          <a:p>
+            <a:pPr indent="0" marL="0">
+              <a:lnSpc>
+                <a:spcPct val="110000"/>
+              </a:lnSpc>
+              <a:buNone/>
+            </a:pPr>
+            <a:r>
+              <a:rPr lang="en-US" sz="1100" dirty="0">
+                <a:solidFill>
+                  <a:srgbClr val="334155"/>
+                </a:solidFill>
+                <a:latin typeface="Malgun Gothic" pitchFamily="34" charset="0"/>
+                <a:ea typeface="Malgun Gothic" pitchFamily="34" charset="-122"/>
+                <a:cs typeface="Malgun Gothic" pitchFamily="34" charset="-120"/>
+              </a:rPr>
+              <a:t>인자: 모델·attn·데이터·시작·개수</a:t>
+            </a:r>
+            <a:endParaRPr lang="en-US" sz="1100" dirty="0"/>
+          </a:p>
+        </p:txBody>
+      </p:sp>
+      <p:sp>
+        <p:nvSpPr>
+          <p:cNvPr id="25" name="Text 23"/>
+          <p:cNvSpPr/>
+          <p:nvPr/>
+        </p:nvSpPr>
+        <p:spPr>
+          <a:xfrm>
+            <a:off x="457200" y="6400800"/>
+            <a:ext cx="5486400" cy="274320"/>
+          </a:xfrm>
+          <a:prstGeom prst="rect">
+            <a:avLst/>
+          </a:prstGeom>
+          <a:noFill/>
+          <a:ln/>
+        </p:spPr>
+        <p:txBody>
+          <a:bodyPr wrap="square" lIns="0" tIns="0" rIns="0" bIns="0" rtlCol="0" anchor="ctr"/>
+          <a:lstStyle/>
+          <a:p>
+            <a:pPr algn="l" indent="0" marL="0">
+              <a:buNone/>
+            </a:pPr>
+            <a:r>
+              <a:rPr lang="en-US" sz="1000" dirty="0">
+                <a:solidFill>
+                  <a:srgbClr val="64748B"/>
+                </a:solidFill>
+                <a:latin typeface="Malgun Gothic" pitchFamily="34" charset="0"/>
+                <a:ea typeface="Malgun Gothic" pitchFamily="34" charset="-122"/>
+                <a:cs typeface="Malgun Gothic" pitchFamily="34" charset="-120"/>
+              </a:rPr>
+              <a:t>RetroInfer · 기술 심화 세미나</a:t>
+            </a:r>
+            <a:endParaRPr lang="en-US" sz="1000" dirty="0"/>
+          </a:p>
+        </p:txBody>
+      </p:sp>
+      <p:sp>
+        <p:nvSpPr>
+          <p:cNvPr id="26" name="Text 24"/>
+          <p:cNvSpPr/>
+          <p:nvPr/>
+        </p:nvSpPr>
+        <p:spPr>
+          <a:xfrm>
+            <a:off x="11365992" y="6400800"/>
+            <a:ext cx="457200" cy="274320"/>
+          </a:xfrm>
+          <a:prstGeom prst="rect">
+            <a:avLst/>
+          </a:prstGeom>
+          <a:noFill/>
+          <a:ln/>
+        </p:spPr>
+        <p:txBody>
+          <a:bodyPr wrap="square" lIns="0" tIns="0" rIns="0" bIns="0" rtlCol="0" anchor="ctr"/>
+          <a:lstStyle/>
+          <a:p>
+            <a:pPr algn="r" indent="0" marL="0">
+              <a:buNone/>
+            </a:pPr>
+            <a:r>
+              <a:rPr lang="en-US" sz="1000" dirty="0">
+                <a:solidFill>
+                  <a:srgbClr val="64748B"/>
+                </a:solidFill>
+                <a:latin typeface="Malgun Gothic" pitchFamily="34" charset="0"/>
+                <a:ea typeface="Malgun Gothic" pitchFamily="34" charset="-122"/>
+                <a:cs typeface="Malgun Gothic" pitchFamily="34" charset="-120"/>
+              </a:rPr>
+              <a:t>14</a:t>
+            </a:r>
+            <a:endParaRPr lang="en-US" sz="1000" dirty="0"/>
+          </a:p>
+        </p:txBody>
+      </p:sp>
+    </p:spTree>
+  </p:cSld>
+  <p:clrMapOvr>
+    <a:masterClrMapping/>
+  </p:clrMapOvr>
+</p:sld>
+</file>
+
+<file path=ppt/slides/slide15.xml><?xml version="1.0" encoding="utf-8"?>
+<p:sld xmlns:a="http://schemas.openxmlformats.org/drawingml/2006/main" xmlns:r="http://schemas.openxmlformats.org/officeDocument/2006/relationships" xmlns:p="http://schemas.openxmlformats.org/presentationml/2006/main">
+  <p:cSld name="Slide 15">
+    <p:bg>
+      <p:bgPr>
+        <a:solidFill>
+          <a:srgbClr val="FFFFFF"/>
+        </a:solidFill>
+      </p:bgPr>
+    </p:bg>
+    <p:spTree>
+      <p:nvGrpSpPr>
+        <p:cNvPr id="1" name=""/>
+        <p:cNvGrpSpPr/>
+        <p:nvPr/>
+      </p:nvGrpSpPr>
+      <p:grpSpPr>
+        <a:xfrm>
+          <a:off x="0" y="0"/>
+          <a:ext cx="0" cy="0"/>
+          <a:chOff x="0" y="0"/>
+          <a:chExt cx="0" cy="0"/>
+        </a:xfrm>
+      </p:grpSpPr>
+      <p:sp>
+        <p:nvSpPr>
+          <p:cNvPr id="2" name="Text 0"/>
+          <p:cNvSpPr/>
+          <p:nvPr/>
+        </p:nvSpPr>
+        <p:spPr>
+          <a:xfrm>
+            <a:off x="548640" y="411480"/>
+            <a:ext cx="11091672" cy="640080"/>
+          </a:xfrm>
+          <a:prstGeom prst="rect">
+            <a:avLst/>
+          </a:prstGeom>
+          <a:noFill/>
+          <a:ln/>
+        </p:spPr>
+        <p:txBody>
+          <a:bodyPr wrap="square" lIns="0" tIns="0" rIns="0" bIns="0" rtlCol="0" anchor="ctr"/>
+          <a:lstStyle/>
+          <a:p>
+            <a:pPr indent="0" marL="0">
+              <a:buNone/>
+            </a:pPr>
+            <a:r>
+              <a:rPr lang="en-US" sz="3000" b="1" dirty="0">
+                <a:solidFill>
+                  <a:srgbClr val="0F172A"/>
+                </a:solidFill>
+                <a:latin typeface="Malgun Gothic" pitchFamily="34" charset="0"/>
+                <a:ea typeface="Malgun Gothic" pitchFamily="34" charset="-122"/>
+                <a:cs typeface="Malgun Gothic" pitchFamily="34" charset="-120"/>
+              </a:rPr>
+              <a:t>실전 ④ 처리량 재현 &amp; 새 방법 추가</a:t>
+            </a:r>
+            <a:endParaRPr lang="en-US" sz="3000" dirty="0"/>
+          </a:p>
+        </p:txBody>
+      </p:sp>
+      <p:sp>
+        <p:nvSpPr>
+          <p:cNvPr id="3" name="Text 1"/>
+          <p:cNvSpPr/>
+          <p:nvPr/>
+        </p:nvSpPr>
+        <p:spPr>
+          <a:xfrm>
+            <a:off x="566928" y="1060704"/>
+            <a:ext cx="11091672" cy="365760"/>
+          </a:xfrm>
+          <a:prstGeom prst="rect">
+            <a:avLst/>
+          </a:prstGeom>
+          <a:noFill/>
+          <a:ln/>
+        </p:spPr>
+        <p:txBody>
+          <a:bodyPr wrap="square" lIns="0" tIns="0" rIns="0" bIns="0" rtlCol="0" anchor="ctr"/>
+          <a:lstStyle/>
+          <a:p>
+            <a:pPr indent="0" marL="0">
+              <a:buNone/>
+            </a:pPr>
+            <a:r>
+              <a:rPr lang="en-US" sz="1400" b="1" dirty="0">
+                <a:solidFill>
+                  <a:srgbClr val="14B8A6"/>
+                </a:solidFill>
+                <a:latin typeface="Malgun Gothic" pitchFamily="34" charset="0"/>
+                <a:ea typeface="Malgun Gothic" pitchFamily="34" charset="-122"/>
+                <a:cs typeface="Malgun Gothic" pitchFamily="34" charset="-120"/>
+              </a:rPr>
+              <a:t>논문 처리량 재현과 프레임워크 확장</a:t>
+            </a:r>
+            <a:endParaRPr lang="en-US" sz="1400" dirty="0"/>
+          </a:p>
+        </p:txBody>
+      </p:sp>
+      <p:sp>
+        <p:nvSpPr>
+          <p:cNvPr id="4" name="Text 2"/>
+          <p:cNvSpPr/>
+          <p:nvPr/>
+        </p:nvSpPr>
+        <p:spPr>
+          <a:xfrm>
+            <a:off x="548640" y="1783080"/>
+            <a:ext cx="5486400" cy="329184"/>
+          </a:xfrm>
+          <a:prstGeom prst="rect">
+            <a:avLst/>
+          </a:prstGeom>
+          <a:noFill/>
+          <a:ln/>
+        </p:spPr>
+        <p:txBody>
+          <a:bodyPr wrap="square" lIns="0" tIns="0" rIns="0" bIns="0" rtlCol="0" anchor="ctr"/>
+          <a:lstStyle/>
+          <a:p>
+            <a:pPr indent="0" marL="0">
+              <a:buNone/>
+            </a:pPr>
+            <a:r>
+              <a:rPr lang="en-US" sz="1500" b="1" dirty="0">
+                <a:solidFill>
+                  <a:srgbClr val="0F766E"/>
+                </a:solidFill>
+                <a:latin typeface="Malgun Gothic" pitchFamily="34" charset="0"/>
+                <a:ea typeface="Malgun Gothic" pitchFamily="34" charset="-122"/>
+                <a:cs typeface="Malgun Gothic" pitchFamily="34" charset="-120"/>
+              </a:rPr>
+              <a:t>처리량 재현</a:t>
+            </a:r>
+            <a:endParaRPr lang="en-US" sz="1500" dirty="0"/>
+          </a:p>
+        </p:txBody>
+      </p:sp>
+      <p:sp>
+        <p:nvSpPr>
+          <p:cNvPr id="5" name="Shape 3"/>
+          <p:cNvSpPr/>
+          <p:nvPr/>
+        </p:nvSpPr>
+        <p:spPr>
+          <a:xfrm>
+            <a:off x="548640" y="2148840"/>
+            <a:ext cx="5486400" cy="1554480"/>
+          </a:xfrm>
+          <a:prstGeom prst="roundRect">
+            <a:avLst>
+              <a:gd name="adj" fmla="val 3529"/>
+            </a:avLst>
+          </a:prstGeom>
+          <a:solidFill>
+            <a:srgbClr val="0F172A"/>
+          </a:solidFill>
+          <a:ln/>
+        </p:spPr>
+      </p:sp>
+      <p:sp>
+        <p:nvSpPr>
+          <p:cNvPr id="6" name="Text 4"/>
+          <p:cNvSpPr/>
+          <p:nvPr/>
+        </p:nvSpPr>
+        <p:spPr>
+          <a:xfrm>
+            <a:off x="713232" y="2258568"/>
+            <a:ext cx="5157216" cy="1335024"/>
+          </a:xfrm>
+          <a:prstGeom prst="rect">
+            <a:avLst/>
+          </a:prstGeom>
+          <a:noFill/>
+          <a:ln/>
+        </p:spPr>
+        <p:txBody>
+          <a:bodyPr wrap="square" lIns="0" tIns="0" rIns="0" bIns="0" rtlCol="0" anchor="t"/>
+          <a:lstStyle/>
+          <a:p>
+            <a:pPr indent="0" marL="0">
+              <a:lnSpc>
+                <a:spcPct val="114000"/>
+              </a:lnSpc>
+              <a:buNone/>
+            </a:pPr>
+            <a:r>
+              <a:rPr lang="en-US" sz="1200" dirty="0">
+                <a:solidFill>
+                  <a:srgbClr val="E2E8F0"/>
+                </a:solidFill>
+                <a:latin typeface="Consolas" pitchFamily="34" charset="0"/>
+                <a:ea typeface="Consolas" pitchFamily="34" charset="-122"/>
+                <a:cs typeface="Consolas" pitchFamily="34" charset="-120"/>
+              </a:rPr>
+              <a:t>sudo apt install numactl -y</a:t>
+            </a:r>
+            <a:endParaRPr lang="en-US" sz="1200" dirty="0"/>
+          </a:p>
+          <a:p>
+            <a:pPr indent="0" marL="0">
+              <a:lnSpc>
+                <a:spcPct val="114000"/>
+              </a:lnSpc>
+              <a:buNone/>
+            </a:pPr>
+            <a:endParaRPr lang="en-US" sz="1200" dirty="0"/>
+          </a:p>
+          <a:p>
+            <a:pPr indent="0" marL="0">
+              <a:lnSpc>
+                <a:spcPct val="114000"/>
+              </a:lnSpc>
+              <a:buNone/>
+            </a:pPr>
+            <a:r>
+              <a:rPr lang="en-US" sz="1200" dirty="0">
+                <a:solidFill>
+                  <a:srgbClr val="E2E8F0"/>
+                </a:solidFill>
+                <a:latin typeface="Consolas" pitchFamily="34" charset="0"/>
+                <a:ea typeface="Consolas" pitchFamily="34" charset="-122"/>
+                <a:cs typeface="Consolas" pitchFamily="34" charset="-120"/>
+              </a:rPr>
+              <a:t>cd throughput_eval</a:t>
+            </a:r>
+            <a:endParaRPr lang="en-US" sz="1200" dirty="0"/>
+          </a:p>
+          <a:p>
+            <a:pPr indent="0" marL="0">
+              <a:lnSpc>
+                <a:spcPct val="114000"/>
+              </a:lnSpc>
+              <a:buNone/>
+            </a:pPr>
+            <a:r>
+              <a:rPr lang="en-US" sz="1200" dirty="0">
+                <a:solidFill>
+                  <a:srgbClr val="E2E8F0"/>
+                </a:solidFill>
+                <a:latin typeface="Consolas" pitchFamily="34" charset="0"/>
+                <a:ea typeface="Consolas" pitchFamily="34" charset="-122"/>
+                <a:cs typeface="Consolas" pitchFamily="34" charset="-120"/>
+              </a:rPr>
+              <a:t>bash run.sh</a:t>
+            </a:r>
+            <a:endParaRPr lang="en-US" sz="1200" dirty="0"/>
+          </a:p>
+        </p:txBody>
+      </p:sp>
+      <p:sp>
+        <p:nvSpPr>
+          <p:cNvPr id="7" name="Shape 5"/>
+          <p:cNvSpPr/>
+          <p:nvPr/>
+        </p:nvSpPr>
+        <p:spPr>
+          <a:xfrm>
+            <a:off x="548640" y="3840480"/>
+            <a:ext cx="5486400" cy="1280160"/>
+          </a:xfrm>
+          <a:prstGeom prst="roundRect">
+            <a:avLst>
+              <a:gd name="adj" fmla="val 5714"/>
+            </a:avLst>
+          </a:prstGeom>
+          <a:solidFill>
+            <a:srgbClr val="EAF6F4"/>
+          </a:solidFill>
+          <a:ln w="12700">
+            <a:solidFill>
+              <a:srgbClr val="14B8A6"/>
+            </a:solidFill>
+            <a:prstDash val="solid"/>
+          </a:ln>
+        </p:spPr>
+      </p:sp>
+      <p:sp>
+        <p:nvSpPr>
+          <p:cNvPr id="8" name="Text 6"/>
+          <p:cNvSpPr/>
+          <p:nvPr/>
+        </p:nvSpPr>
+        <p:spPr>
+          <a:xfrm>
+            <a:off x="777240" y="3977640"/>
+            <a:ext cx="5029200" cy="1005840"/>
+          </a:xfrm>
+          <a:prstGeom prst="rect">
+            <a:avLst/>
+          </a:prstGeom>
+          <a:noFill/>
+          <a:ln/>
+        </p:spPr>
+        <p:txBody>
+          <a:bodyPr wrap="square" lIns="0" tIns="0" rIns="0" bIns="0" rtlCol="0" anchor="t"/>
+          <a:lstStyle/>
+          <a:p>
+            <a:pPr indent="0" marL="0">
+              <a:lnSpc>
+                <a:spcPct val="115000"/>
+              </a:lnSpc>
+              <a:buNone/>
+            </a:pPr>
+            <a:r>
+              <a:rPr lang="en-US" sz="1200" b="1" dirty="0">
+                <a:solidFill>
+                  <a:srgbClr val="0F766E"/>
+                </a:solidFill>
+                <a:latin typeface="Malgun Gothic" pitchFamily="34" charset="0"/>
+                <a:ea typeface="Malgun Gothic" pitchFamily="34" charset="-122"/>
+                <a:cs typeface="Malgun Gothic" pitchFamily="34" charset="-120"/>
+              </a:rPr>
+              <a:t>실험 환경 (논문)
+</a:t>
+            </a:r>
+            <a:pPr indent="0" marL="0">
+              <a:lnSpc>
+                <a:spcPct val="115000"/>
+              </a:lnSpc>
+              <a:buNone/>
+            </a:pPr>
+            <a:r>
+              <a:rPr lang="en-US" sz="1200" dirty="0">
+                <a:solidFill>
+                  <a:srgbClr val="134E4A"/>
+                </a:solidFill>
+                <a:latin typeface="Malgun Gothic" pitchFamily="34" charset="0"/>
+                <a:ea typeface="Malgun Gothic" pitchFamily="34" charset="-122"/>
+                <a:cs typeface="Malgun Gothic" pitchFamily="34" charset="-120"/>
+              </a:rPr>
+              <a:t>Azure 4-NUMA A100 머신 · NUMA 노드당 24코어 · 475GB CPU · 80GB A100 ×2</a:t>
+            </a:r>
+            <a:endParaRPr lang="en-US" sz="1200" dirty="0"/>
+          </a:p>
+        </p:txBody>
+      </p:sp>
+      <p:sp>
+        <p:nvSpPr>
+          <p:cNvPr id="9" name="Text 7"/>
+          <p:cNvSpPr/>
+          <p:nvPr/>
+        </p:nvSpPr>
+        <p:spPr>
+          <a:xfrm>
+            <a:off x="6309360" y="1783080"/>
+            <a:ext cx="5303520" cy="329184"/>
+          </a:xfrm>
+          <a:prstGeom prst="rect">
+            <a:avLst/>
+          </a:prstGeom>
+          <a:noFill/>
+          <a:ln/>
+        </p:spPr>
+        <p:txBody>
+          <a:bodyPr wrap="square" lIns="0" tIns="0" rIns="0" bIns="0" rtlCol="0" anchor="ctr"/>
+          <a:lstStyle/>
+          <a:p>
+            <a:pPr indent="0" marL="0">
+              <a:buNone/>
+            </a:pPr>
+            <a:r>
+              <a:rPr lang="en-US" sz="1500" b="1" dirty="0">
+                <a:solidFill>
+                  <a:srgbClr val="1E3A8A"/>
+                </a:solidFill>
+                <a:latin typeface="Malgun Gothic" pitchFamily="34" charset="0"/>
+                <a:ea typeface="Malgun Gothic" pitchFamily="34" charset="-122"/>
+                <a:cs typeface="Malgun Gothic" pitchFamily="34" charset="-120"/>
+              </a:rPr>
+              <a:t>새 희소성 방법 추가 — 5단계</a:t>
+            </a:r>
+            <a:endParaRPr lang="en-US" sz="1500" dirty="0"/>
+          </a:p>
+        </p:txBody>
+      </p:sp>
+      <p:sp>
+        <p:nvSpPr>
+          <p:cNvPr id="10" name="Shape 8"/>
+          <p:cNvSpPr/>
+          <p:nvPr/>
+        </p:nvSpPr>
+        <p:spPr>
+          <a:xfrm>
+            <a:off x="6309360" y="2194560"/>
+            <a:ext cx="384048" cy="384048"/>
+          </a:xfrm>
+          <a:prstGeom prst="roundRect">
+            <a:avLst>
+              <a:gd name="adj" fmla="val 21429"/>
+            </a:avLst>
+          </a:prstGeom>
+          <a:solidFill>
+            <a:srgbClr val="1E3A8A"/>
+          </a:solidFill>
+          <a:ln/>
+        </p:spPr>
+      </p:sp>
+      <p:sp>
+        <p:nvSpPr>
+          <p:cNvPr id="11" name="Text 9"/>
+          <p:cNvSpPr/>
+          <p:nvPr/>
+        </p:nvSpPr>
+        <p:spPr>
+          <a:xfrm>
+            <a:off x="6309360" y="2194560"/>
+            <a:ext cx="384048" cy="384048"/>
+          </a:xfrm>
+          <a:prstGeom prst="rect">
+            <a:avLst/>
+          </a:prstGeom>
+          <a:noFill/>
+          <a:ln/>
+        </p:spPr>
+        <p:txBody>
+          <a:bodyPr wrap="square" lIns="0" tIns="0" rIns="0" bIns="0" rtlCol="0" anchor="ctr"/>
+          <a:lstStyle/>
+          <a:p>
+            <a:pPr algn="ctr" indent="0" marL="0">
+              <a:buNone/>
+            </a:pPr>
+            <a:r>
+              <a:rPr lang="en-US" sz="1500" b="1" dirty="0">
+                <a:solidFill>
+                  <a:srgbClr val="FFFFFF"/>
+                </a:solidFill>
+                <a:latin typeface="Malgun Gothic" pitchFamily="34" charset="0"/>
+                <a:ea typeface="Malgun Gothic" pitchFamily="34" charset="-122"/>
+                <a:cs typeface="Malgun Gothic" pitchFamily="34" charset="-120"/>
+              </a:rPr>
+              <a:t>1</a:t>
+            </a:r>
+            <a:endParaRPr lang="en-US" sz="1500" dirty="0"/>
+          </a:p>
+        </p:txBody>
+      </p:sp>
+      <p:sp>
+        <p:nvSpPr>
+          <p:cNvPr id="12" name="Text 10"/>
+          <p:cNvSpPr/>
+          <p:nvPr/>
+        </p:nvSpPr>
+        <p:spPr>
+          <a:xfrm>
+            <a:off x="6858000" y="2212848"/>
+            <a:ext cx="4754880" cy="457200"/>
+          </a:xfrm>
+          <a:prstGeom prst="rect">
+            <a:avLst/>
+          </a:prstGeom>
+          <a:noFill/>
+          <a:ln/>
+        </p:spPr>
+        <p:txBody>
+          <a:bodyPr wrap="square" lIns="0" tIns="0" rIns="0" bIns="0" rtlCol="0" anchor="ctr"/>
+          <a:lstStyle/>
+          <a:p>
+            <a:pPr indent="0" marL="0">
+              <a:lnSpc>
+                <a:spcPct val="100000"/>
+              </a:lnSpc>
+              <a:buNone/>
+            </a:pPr>
+            <a:r>
+              <a:rPr lang="en-US" sz="1150" b="1" dirty="0">
+                <a:solidFill>
+                  <a:srgbClr val="0F766E"/>
+                </a:solidFill>
+                <a:latin typeface="Consolas" pitchFamily="34" charset="0"/>
+                <a:ea typeface="Consolas" pitchFamily="34" charset="-122"/>
+                <a:cs typeface="Consolas" pitchFamily="34" charset="-120"/>
+              </a:rPr>
+              <a:t>cache_hub/  </a:t>
+            </a:r>
+            <a:pPr indent="0" marL="0">
+              <a:lnSpc>
+                <a:spcPct val="100000"/>
+              </a:lnSpc>
+              <a:buNone/>
+            </a:pPr>
+            <a:r>
+              <a:rPr lang="en-US" sz="1150" dirty="0">
+                <a:solidFill>
+                  <a:srgbClr val="334155"/>
+                </a:solidFill>
+                <a:latin typeface="Malgun Gothic" pitchFamily="34" charset="0"/>
+                <a:ea typeface="Malgun Gothic" pitchFamily="34" charset="-122"/>
+                <a:cs typeface="Malgun Gothic" pitchFamily="34" charset="-120"/>
+              </a:rPr>
+              <a:t>KV 캐시 관리 로직 추가</a:t>
+            </a:r>
+            <a:endParaRPr lang="en-US" sz="1150" dirty="0"/>
+          </a:p>
+        </p:txBody>
+      </p:sp>
+      <p:sp>
+        <p:nvSpPr>
+          <p:cNvPr id="13" name="Shape 11"/>
+          <p:cNvSpPr/>
+          <p:nvPr/>
+        </p:nvSpPr>
+        <p:spPr>
+          <a:xfrm>
+            <a:off x="6309360" y="2907792"/>
+            <a:ext cx="384048" cy="384048"/>
+          </a:xfrm>
+          <a:prstGeom prst="roundRect">
+            <a:avLst>
+              <a:gd name="adj" fmla="val 21429"/>
+            </a:avLst>
+          </a:prstGeom>
+          <a:solidFill>
+            <a:srgbClr val="1E3A8A"/>
+          </a:solidFill>
+          <a:ln/>
+        </p:spPr>
+      </p:sp>
+      <p:sp>
+        <p:nvSpPr>
+          <p:cNvPr id="14" name="Text 12"/>
+          <p:cNvSpPr/>
+          <p:nvPr/>
+        </p:nvSpPr>
+        <p:spPr>
+          <a:xfrm>
+            <a:off x="6309360" y="2907792"/>
+            <a:ext cx="384048" cy="384048"/>
+          </a:xfrm>
+          <a:prstGeom prst="rect">
+            <a:avLst/>
+          </a:prstGeom>
+          <a:noFill/>
+          <a:ln/>
+        </p:spPr>
+        <p:txBody>
+          <a:bodyPr wrap="square" lIns="0" tIns="0" rIns="0" bIns="0" rtlCol="0" anchor="ctr"/>
+          <a:lstStyle/>
+          <a:p>
+            <a:pPr algn="ctr" indent="0" marL="0">
+              <a:buNone/>
+            </a:pPr>
+            <a:r>
+              <a:rPr lang="en-US" sz="1500" b="1" dirty="0">
+                <a:solidFill>
+                  <a:srgbClr val="FFFFFF"/>
+                </a:solidFill>
+                <a:latin typeface="Malgun Gothic" pitchFamily="34" charset="0"/>
+                <a:ea typeface="Malgun Gothic" pitchFamily="34" charset="-122"/>
+                <a:cs typeface="Malgun Gothic" pitchFamily="34" charset="-120"/>
+              </a:rPr>
+              <a:t>2</a:t>
+            </a:r>
+            <a:endParaRPr lang="en-US" sz="1500" dirty="0"/>
+          </a:p>
+        </p:txBody>
+      </p:sp>
+      <p:sp>
+        <p:nvSpPr>
+          <p:cNvPr id="15" name="Text 13"/>
+          <p:cNvSpPr/>
+          <p:nvPr/>
+        </p:nvSpPr>
+        <p:spPr>
+          <a:xfrm>
+            <a:off x="6858000" y="2926080"/>
+            <a:ext cx="4754880" cy="457200"/>
+          </a:xfrm>
+          <a:prstGeom prst="rect">
+            <a:avLst/>
+          </a:prstGeom>
+          <a:noFill/>
+          <a:ln/>
+        </p:spPr>
+        <p:txBody>
+          <a:bodyPr wrap="square" lIns="0" tIns="0" rIns="0" bIns="0" rtlCol="0" anchor="ctr"/>
+          <a:lstStyle/>
+          <a:p>
+            <a:pPr indent="0" marL="0">
+              <a:lnSpc>
+                <a:spcPct val="100000"/>
+              </a:lnSpc>
+              <a:buNone/>
+            </a:pPr>
+            <a:r>
+              <a:rPr lang="en-US" sz="1150" b="1" dirty="0">
+                <a:solidFill>
+                  <a:srgbClr val="0F766E"/>
+                </a:solidFill>
+                <a:latin typeface="Consolas" pitchFamily="34" charset="0"/>
+                <a:ea typeface="Consolas" pitchFamily="34" charset="-122"/>
+                <a:cs typeface="Consolas" pitchFamily="34" charset="-120"/>
+              </a:rPr>
+              <a:t>attn_hub/  </a:t>
+            </a:r>
+            <a:pPr indent="0" marL="0">
+              <a:lnSpc>
+                <a:spcPct val="100000"/>
+              </a:lnSpc>
+              <a:buNone/>
+            </a:pPr>
+            <a:r>
+              <a:rPr lang="en-US" sz="1150" dirty="0">
+                <a:solidFill>
+                  <a:srgbClr val="334155"/>
+                </a:solidFill>
+                <a:latin typeface="Malgun Gothic" pitchFamily="34" charset="0"/>
+                <a:ea typeface="Malgun Gothic" pitchFamily="34" charset="-122"/>
+                <a:cs typeface="Malgun Gothic" pitchFamily="34" charset="-120"/>
+              </a:rPr>
+              <a:t>어텐션 연산 로직 추가</a:t>
+            </a:r>
+            <a:endParaRPr lang="en-US" sz="1150" dirty="0"/>
+          </a:p>
+        </p:txBody>
+      </p:sp>
+      <p:sp>
+        <p:nvSpPr>
+          <p:cNvPr id="16" name="Shape 14"/>
+          <p:cNvSpPr/>
+          <p:nvPr/>
+        </p:nvSpPr>
+        <p:spPr>
+          <a:xfrm>
+            <a:off x="6309360" y="3621024"/>
+            <a:ext cx="384048" cy="384048"/>
+          </a:xfrm>
+          <a:prstGeom prst="roundRect">
+            <a:avLst>
+              <a:gd name="adj" fmla="val 21429"/>
+            </a:avLst>
+          </a:prstGeom>
+          <a:solidFill>
+            <a:srgbClr val="1E3A8A"/>
+          </a:solidFill>
+          <a:ln/>
+        </p:spPr>
+      </p:sp>
+      <p:sp>
+        <p:nvSpPr>
+          <p:cNvPr id="17" name="Text 15"/>
+          <p:cNvSpPr/>
+          <p:nvPr/>
+        </p:nvSpPr>
+        <p:spPr>
+          <a:xfrm>
+            <a:off x="6309360" y="3621024"/>
+            <a:ext cx="384048" cy="384048"/>
+          </a:xfrm>
+          <a:prstGeom prst="rect">
+            <a:avLst/>
+          </a:prstGeom>
+          <a:noFill/>
+          <a:ln/>
+        </p:spPr>
+        <p:txBody>
+          <a:bodyPr wrap="square" lIns="0" tIns="0" rIns="0" bIns="0" rtlCol="0" anchor="ctr"/>
+          <a:lstStyle/>
+          <a:p>
+            <a:pPr algn="ctr" indent="0" marL="0">
+              <a:buNone/>
+            </a:pPr>
+            <a:r>
+              <a:rPr lang="en-US" sz="1500" b="1" dirty="0">
+                <a:solidFill>
+                  <a:srgbClr val="FFFFFF"/>
+                </a:solidFill>
+                <a:latin typeface="Malgun Gothic" pitchFamily="34" charset="0"/>
+                <a:ea typeface="Malgun Gothic" pitchFamily="34" charset="-122"/>
+                <a:cs typeface="Malgun Gothic" pitchFamily="34" charset="-120"/>
+              </a:rPr>
+              <a:t>3</a:t>
+            </a:r>
+            <a:endParaRPr lang="en-US" sz="1500" dirty="0"/>
+          </a:p>
+        </p:txBody>
+      </p:sp>
+      <p:sp>
+        <p:nvSpPr>
+          <p:cNvPr id="18" name="Text 16"/>
+          <p:cNvSpPr/>
+          <p:nvPr/>
+        </p:nvSpPr>
+        <p:spPr>
+          <a:xfrm>
+            <a:off x="6858000" y="3639312"/>
+            <a:ext cx="4754880" cy="457200"/>
+          </a:xfrm>
+          <a:prstGeom prst="rect">
+            <a:avLst/>
+          </a:prstGeom>
+          <a:noFill/>
+          <a:ln/>
+        </p:spPr>
+        <p:txBody>
+          <a:bodyPr wrap="square" lIns="0" tIns="0" rIns="0" bIns="0" rtlCol="0" anchor="ctr"/>
+          <a:lstStyle/>
+          <a:p>
+            <a:pPr indent="0" marL="0">
+              <a:lnSpc>
+                <a:spcPct val="100000"/>
+              </a:lnSpc>
+              <a:buNone/>
+            </a:pPr>
+            <a:r>
+              <a:rPr lang="en-US" sz="1150" b="1" dirty="0">
+                <a:solidFill>
+                  <a:srgbClr val="0F766E"/>
+                </a:solidFill>
+                <a:latin typeface="Consolas" pitchFamily="34" charset="0"/>
+                <a:ea typeface="Consolas" pitchFamily="34" charset="-122"/>
+                <a:cs typeface="Consolas" pitchFamily="34" charset="-120"/>
+              </a:rPr>
+              <a:t>config/config.py  </a:t>
+            </a:r>
+            <a:pPr indent="0" marL="0">
+              <a:lnSpc>
+                <a:spcPct val="100000"/>
+              </a:lnSpc>
+              <a:buNone/>
+            </a:pPr>
+            <a:r>
+              <a:rPr lang="en-US" sz="1150" dirty="0">
+                <a:solidFill>
+                  <a:srgbClr val="334155"/>
+                </a:solidFill>
+                <a:latin typeface="Malgun Gothic" pitchFamily="34" charset="0"/>
+                <a:ea typeface="Malgun Gothic" pitchFamily="34" charset="-122"/>
+                <a:cs typeface="Malgun Gothic" pitchFamily="34" charset="-120"/>
+              </a:rPr>
+              <a:t>설정 옵션 등록</a:t>
+            </a:r>
+            <a:endParaRPr lang="en-US" sz="1150" dirty="0"/>
+          </a:p>
+        </p:txBody>
+      </p:sp>
+      <p:sp>
+        <p:nvSpPr>
+          <p:cNvPr id="19" name="Shape 17"/>
+          <p:cNvSpPr/>
+          <p:nvPr/>
+        </p:nvSpPr>
+        <p:spPr>
+          <a:xfrm>
+            <a:off x="6309360" y="4334256"/>
+            <a:ext cx="384048" cy="384048"/>
+          </a:xfrm>
+          <a:prstGeom prst="roundRect">
+            <a:avLst>
+              <a:gd name="adj" fmla="val 21429"/>
+            </a:avLst>
+          </a:prstGeom>
+          <a:solidFill>
+            <a:srgbClr val="1E3A8A"/>
+          </a:solidFill>
+          <a:ln/>
+        </p:spPr>
+      </p:sp>
+      <p:sp>
+        <p:nvSpPr>
+          <p:cNvPr id="20" name="Text 18"/>
+          <p:cNvSpPr/>
+          <p:nvPr/>
+        </p:nvSpPr>
+        <p:spPr>
+          <a:xfrm>
+            <a:off x="6309360" y="4334256"/>
+            <a:ext cx="384048" cy="384048"/>
+          </a:xfrm>
+          <a:prstGeom prst="rect">
+            <a:avLst/>
+          </a:prstGeom>
+          <a:noFill/>
+          <a:ln/>
+        </p:spPr>
+        <p:txBody>
+          <a:bodyPr wrap="square" lIns="0" tIns="0" rIns="0" bIns="0" rtlCol="0" anchor="ctr"/>
+          <a:lstStyle/>
+          <a:p>
+            <a:pPr algn="ctr" indent="0" marL="0">
+              <a:buNone/>
+            </a:pPr>
+            <a:r>
+              <a:rPr lang="en-US" sz="1500" b="1" dirty="0">
+                <a:solidFill>
+                  <a:srgbClr val="FFFFFF"/>
+                </a:solidFill>
+                <a:latin typeface="Malgun Gothic" pitchFamily="34" charset="0"/>
+                <a:ea typeface="Malgun Gothic" pitchFamily="34" charset="-122"/>
+                <a:cs typeface="Malgun Gothic" pitchFamily="34" charset="-120"/>
+              </a:rPr>
+              <a:t>4</a:t>
+            </a:r>
+            <a:endParaRPr lang="en-US" sz="1500" dirty="0"/>
+          </a:p>
+        </p:txBody>
+      </p:sp>
+      <p:sp>
+        <p:nvSpPr>
+          <p:cNvPr id="21" name="Text 19"/>
+          <p:cNvSpPr/>
+          <p:nvPr/>
+        </p:nvSpPr>
+        <p:spPr>
+          <a:xfrm>
+            <a:off x="6858000" y="4352544"/>
+            <a:ext cx="4754880" cy="457200"/>
+          </a:xfrm>
+          <a:prstGeom prst="rect">
+            <a:avLst/>
+          </a:prstGeom>
+          <a:noFill/>
+          <a:ln/>
+        </p:spPr>
+        <p:txBody>
+          <a:bodyPr wrap="square" lIns="0" tIns="0" rIns="0" bIns="0" rtlCol="0" anchor="ctr"/>
+          <a:lstStyle/>
+          <a:p>
+            <a:pPr indent="0" marL="0">
+              <a:lnSpc>
+                <a:spcPct val="100000"/>
+              </a:lnSpc>
+              <a:buNone/>
+            </a:pPr>
+            <a:r>
+              <a:rPr lang="en-US" sz="1150" b="1" dirty="0">
+                <a:solidFill>
+                  <a:srgbClr val="0F766E"/>
+                </a:solidFill>
+                <a:latin typeface="Consolas" pitchFamily="34" charset="0"/>
+                <a:ea typeface="Consolas" pitchFamily="34" charset="-122"/>
+                <a:cs typeface="Consolas" pitchFamily="34" charset="-120"/>
+              </a:rPr>
+              <a:t>model_hub/llama.py · qwen.py  </a:t>
+            </a:r>
+            <a:pPr indent="0" marL="0">
+              <a:lnSpc>
+                <a:spcPct val="100000"/>
+              </a:lnSpc>
+              <a:buNone/>
+            </a:pPr>
+            <a:r>
+              <a:rPr lang="en-US" sz="1150" dirty="0">
+                <a:solidFill>
+                  <a:srgbClr val="334155"/>
+                </a:solidFill>
+                <a:latin typeface="Malgun Gothic" pitchFamily="34" charset="0"/>
+                <a:ea typeface="Malgun Gothic" pitchFamily="34" charset="-122"/>
+                <a:cs typeface="Malgun Gothic" pitchFamily="34" charset="-120"/>
+              </a:rPr>
+              <a:t>init_kv_cache · decode_attention · parameter_move 갱신</a:t>
+            </a:r>
+            <a:endParaRPr lang="en-US" sz="1150" dirty="0"/>
+          </a:p>
+        </p:txBody>
+      </p:sp>
+      <p:sp>
+        <p:nvSpPr>
+          <p:cNvPr id="22" name="Shape 20"/>
+          <p:cNvSpPr/>
+          <p:nvPr/>
+        </p:nvSpPr>
+        <p:spPr>
+          <a:xfrm>
+            <a:off x="6309360" y="5047488"/>
+            <a:ext cx="384048" cy="384048"/>
+          </a:xfrm>
+          <a:prstGeom prst="roundRect">
+            <a:avLst>
+              <a:gd name="adj" fmla="val 21429"/>
+            </a:avLst>
+          </a:prstGeom>
+          <a:solidFill>
+            <a:srgbClr val="1E3A8A"/>
+          </a:solidFill>
+          <a:ln/>
+        </p:spPr>
+      </p:sp>
+      <p:sp>
+        <p:nvSpPr>
+          <p:cNvPr id="23" name="Text 21"/>
+          <p:cNvSpPr/>
+          <p:nvPr/>
+        </p:nvSpPr>
+        <p:spPr>
+          <a:xfrm>
+            <a:off x="6309360" y="5047488"/>
+            <a:ext cx="384048" cy="384048"/>
+          </a:xfrm>
+          <a:prstGeom prst="rect">
+            <a:avLst/>
+          </a:prstGeom>
+          <a:noFill/>
+          <a:ln/>
+        </p:spPr>
+        <p:txBody>
+          <a:bodyPr wrap="square" lIns="0" tIns="0" rIns="0" bIns="0" rtlCol="0" anchor="ctr"/>
+          <a:lstStyle/>
+          <a:p>
+            <a:pPr algn="ctr" indent="0" marL="0">
+              <a:buNone/>
+            </a:pPr>
+            <a:r>
+              <a:rPr lang="en-US" sz="1500" b="1" dirty="0">
+                <a:solidFill>
+                  <a:srgbClr val="FFFFFF"/>
+                </a:solidFill>
+                <a:latin typeface="Malgun Gothic" pitchFamily="34" charset="0"/>
+                <a:ea typeface="Malgun Gothic" pitchFamily="34" charset="-122"/>
+                <a:cs typeface="Malgun Gothic" pitchFamily="34" charset="-120"/>
+              </a:rPr>
+              <a:t>5</a:t>
+            </a:r>
+            <a:endParaRPr lang="en-US" sz="1500" dirty="0"/>
+          </a:p>
+        </p:txBody>
+      </p:sp>
+      <p:sp>
+        <p:nvSpPr>
+          <p:cNvPr id="24" name="Text 22"/>
+          <p:cNvSpPr/>
+          <p:nvPr/>
+        </p:nvSpPr>
+        <p:spPr>
+          <a:xfrm>
+            <a:off x="6858000" y="5065776"/>
+            <a:ext cx="4754880" cy="457200"/>
+          </a:xfrm>
+          <a:prstGeom prst="rect">
+            <a:avLst/>
+          </a:prstGeom>
+          <a:noFill/>
+          <a:ln/>
+        </p:spPr>
+        <p:txBody>
+          <a:bodyPr wrap="square" lIns="0" tIns="0" rIns="0" bIns="0" rtlCol="0" anchor="ctr"/>
+          <a:lstStyle/>
+          <a:p>
+            <a:pPr indent="0" marL="0">
+              <a:lnSpc>
+                <a:spcPct val="100000"/>
+              </a:lnSpc>
+              <a:buNone/>
+            </a:pPr>
+            <a:r>
+              <a:rPr lang="en-US" sz="1150" b="1" dirty="0">
+                <a:solidFill>
+                  <a:srgbClr val="0F766E"/>
+                </a:solidFill>
+                <a:latin typeface="Consolas" pitchFamily="34" charset="0"/>
+                <a:ea typeface="Consolas" pitchFamily="34" charset="-122"/>
+                <a:cs typeface="Consolas" pitchFamily="34" charset="-120"/>
+              </a:rPr>
+              <a:t>--attn_type  </a:t>
+            </a:r>
+            <a:pPr indent="0" marL="0">
+              <a:lnSpc>
+                <a:spcPct val="100000"/>
+              </a:lnSpc>
+              <a:buNone/>
+            </a:pPr>
+            <a:r>
+              <a:rPr lang="en-US" sz="1150" dirty="0">
+                <a:solidFill>
+                  <a:srgbClr val="334155"/>
+                </a:solidFill>
+                <a:latin typeface="Malgun Gothic" pitchFamily="34" charset="0"/>
+                <a:ea typeface="Malgun Gothic" pitchFamily="34" charset="-122"/>
+                <a:cs typeface="Malgun Gothic" pitchFamily="34" charset="-120"/>
+              </a:rPr>
+              <a:t>지정해 실행</a:t>
+            </a:r>
+            <a:endParaRPr lang="en-US" sz="1150" dirty="0"/>
+          </a:p>
+        </p:txBody>
+      </p:sp>
+      <p:sp>
+        <p:nvSpPr>
+          <p:cNvPr id="25" name="Text 23"/>
+          <p:cNvSpPr/>
+          <p:nvPr/>
+        </p:nvSpPr>
+        <p:spPr>
+          <a:xfrm>
+            <a:off x="457200" y="6400800"/>
+            <a:ext cx="5486400" cy="274320"/>
+          </a:xfrm>
+          <a:prstGeom prst="rect">
+            <a:avLst/>
+          </a:prstGeom>
+          <a:noFill/>
+          <a:ln/>
+        </p:spPr>
+        <p:txBody>
+          <a:bodyPr wrap="square" lIns="0" tIns="0" rIns="0" bIns="0" rtlCol="0" anchor="ctr"/>
+          <a:lstStyle/>
+          <a:p>
+            <a:pPr algn="l" indent="0" marL="0">
+              <a:buNone/>
+            </a:pPr>
+            <a:r>
+              <a:rPr lang="en-US" sz="1000" dirty="0">
+                <a:solidFill>
+                  <a:srgbClr val="64748B"/>
+                </a:solidFill>
+                <a:latin typeface="Malgun Gothic" pitchFamily="34" charset="0"/>
+                <a:ea typeface="Malgun Gothic" pitchFamily="34" charset="-122"/>
+                <a:cs typeface="Malgun Gothic" pitchFamily="34" charset="-120"/>
+              </a:rPr>
+              <a:t>RetroInfer · 기술 심화 세미나</a:t>
+            </a:r>
+            <a:endParaRPr lang="en-US" sz="1000" dirty="0"/>
+          </a:p>
+        </p:txBody>
+      </p:sp>
+      <p:sp>
+        <p:nvSpPr>
+          <p:cNvPr id="26" name="Text 24"/>
+          <p:cNvSpPr/>
+          <p:nvPr/>
+        </p:nvSpPr>
+        <p:spPr>
+          <a:xfrm>
+            <a:off x="11365992" y="6400800"/>
+            <a:ext cx="457200" cy="274320"/>
+          </a:xfrm>
+          <a:prstGeom prst="rect">
+            <a:avLst/>
+          </a:prstGeom>
+          <a:noFill/>
+          <a:ln/>
+        </p:spPr>
+        <p:txBody>
+          <a:bodyPr wrap="square" lIns="0" tIns="0" rIns="0" bIns="0" rtlCol="0" anchor="ctr"/>
+          <a:lstStyle/>
+          <a:p>
+            <a:pPr algn="r" indent="0" marL="0">
+              <a:buNone/>
+            </a:pPr>
+            <a:r>
+              <a:rPr lang="en-US" sz="1000" dirty="0">
+                <a:solidFill>
+                  <a:srgbClr val="64748B"/>
+                </a:solidFill>
+                <a:latin typeface="Malgun Gothic" pitchFamily="34" charset="0"/>
+                <a:ea typeface="Malgun Gothic" pitchFamily="34" charset="-122"/>
+                <a:cs typeface="Malgun Gothic" pitchFamily="34" charset="-120"/>
+              </a:rPr>
+              <a:t>15</a:t>
+            </a:r>
+            <a:endParaRPr lang="en-US" sz="1000" dirty="0"/>
+          </a:p>
+        </p:txBody>
+      </p:sp>
+    </p:spTree>
+  </p:cSld>
+  <p:clrMapOvr>
+    <a:masterClrMapping/>
+  </p:clrMapOvr>
+</p:sld>
+</file>
+
+<file path=ppt/slides/slide16.xml><?xml version="1.0" encoding="utf-8"?>
+<p:sld xmlns:a="http://schemas.openxmlformats.org/drawingml/2006/main" xmlns:r="http://schemas.openxmlformats.org/officeDocument/2006/relationships" xmlns:p="http://schemas.openxmlformats.org/presentationml/2006/main">
+  <p:cSld name="Slide 16">
+    <p:bg>
+      <p:bgPr>
+        <a:solidFill>
           <a:srgbClr val="0C1B33"/>
         </a:solidFill>
       </p:bgPr>
@@ -5526,7 +9825,7 @@
                 <a:ea typeface="Malgun Gothic" pitchFamily="34" charset="-122"/>
                 <a:cs typeface="Malgun Gothic" pitchFamily="34" charset="-120"/>
               </a:rPr>
-              <a:t>12</a:t>
+              <a:t>16</a:t>
             </a:r>
             <a:endParaRPr lang="en-US" sz="1000" dirty="0"/>
           </a:p>

</xml_diff>